<commit_message>
Docs: record the real Azure deployment (region, VM size, snags, cloud push test)
</commit_message>
<xml_diff>
--- a/docs/PingHome-Progress-Presentation.pptx
+++ b/docs/PingHome-Progress-Presentation.pptx
@@ -4,6 +4,9 @@
   <p:sldMasterIdLst>
     <p:sldMasterId id="2147483648" r:id="rId1"/>
   </p:sldMasterIdLst>
+  <p:notesMasterIdLst>
+    <p:notesMasterId r:id="rId18"/>
+  </p:notesMasterIdLst>
   <p:sldIdLst>
     <p:sldId id="256" r:id="rId2"/>
     <p:sldId id="257" r:id="rId3"/>
@@ -22,10 +25,7 @@
     <p:sldId id="270" r:id="rId16"/>
     <p:sldId id="271" r:id="rId17"/>
   </p:sldIdLst>
-  <p:notesMasterIdLst>
-    <p:notesMasterId r:id="rId18"/>
-  </p:notesMasterIdLst>
-  <p:sldSz cx="9144000" cy="5143500"/>
+  <p:sldSz cx="9144000" cy="5143500" type="screen16x9"/>
   <p:notesSz cx="5143500" cy="9144000"/>
   <p:defaultTextStyle>
     <a:lvl1pPr marL="0" algn="l" defTabSz="914400" rtl="0" eaLnBrk="1" latinLnBrk="0" hangingPunct="1">
@@ -119,6 +119,11 @@
       </a:defRPr>
     </a:lvl9pPr>
   </p:defaultTextStyle>
+  <p:extLst>
+    <p:ext uri="{EFAFB233-063F-42B5-8137-9DF3F51BA10A}">
+      <p15:sldGuideLst xmlns:p15="http://schemas.microsoft.com/office/powerpoint/2012/main"/>
+    </p:ext>
+  </p:extLst>
 </p:presentation>
 </file>
 
@@ -144,234 +149,10 @@
           <a:chExt cx="0" cy="0"/>
         </a:xfrm>
       </p:grpSpPr>
-      <p:sp>
-        <p:nvSpPr>
-          <p:cNvPr id="2" name="Header Placeholder 1"/>
-          <p:cNvSpPr>
-            <a:spLocks noGrp="1"/>
-          </p:cNvSpPr>
-          <p:nvPr>
-            <p:ph type="hdr" sz="quarter"/>
-          </p:nvPr>
-        </p:nvSpPr>
-        <p:spPr>
-          <a:xfrm>
-            <a:off x="0" y="0"/>
-            <a:ext cx="2971800" cy="458788"/>
-          </a:xfrm>
-          <a:prstGeom prst="rect">
-            <a:avLst/>
-          </a:prstGeom>
-        </p:spPr>
-        <p:txBody>
-          <a:bodyPr vert="horz" lIns="91440" tIns="45720" rIns="91440" bIns="45720" rtlCol="0"/>
-          <a:lstStyle>
-            <a:lvl1pPr algn="l">
-              <a:defRPr sz="1200"/>
-            </a:lvl1pPr>
-          </a:lstStyle>
-          <a:p>
-            <a:endParaRPr lang="en-US"/>
-          </a:p>
-        </p:txBody>
-      </p:sp>
-      <p:sp>
-        <p:nvSpPr>
-          <p:cNvPr id="3" name="Date Placeholder 2"/>
-          <p:cNvSpPr>
-            <a:spLocks noGrp="1"/>
-          </p:cNvSpPr>
-          <p:nvPr>
-            <p:ph type="dt" idx="1"/>
-          </p:nvPr>
-        </p:nvSpPr>
-        <p:spPr>
-          <a:xfrm>
-            <a:off x="3884613" y="0"/>
-            <a:ext cx="2971800" cy="458788"/>
-          </a:xfrm>
-          <a:prstGeom prst="rect">
-            <a:avLst/>
-          </a:prstGeom>
-        </p:spPr>
-        <p:txBody>
-          <a:bodyPr vert="horz" lIns="91440" tIns="45720" rIns="91440" bIns="45720" rtlCol="0"/>
-          <a:lstStyle>
-            <a:lvl1pPr algn="r">
-              <a:defRPr sz="1200"/>
-            </a:lvl1pPr>
-          </a:lstStyle>
-          <a:p>
-            <a:fld id="{5282F153-3F37-0F45-9E97-73ACFA13230C}" type="datetimeFigureOut">
-              <a:rPr lang="en-US"/>
-              <a:t>7/23/19</a:t>
-            </a:fld>
-            <a:endParaRPr lang="en-US"/>
-          </a:p>
-        </p:txBody>
-      </p:sp>
-      <p:sp>
-        <p:nvSpPr>
-          <p:cNvPr id="4" name="Slide Image Placeholder 3"/>
-          <p:cNvSpPr>
-            <a:spLocks noGrp="1" noRot="1" noChangeAspect="1"/>
-          </p:cNvSpPr>
-          <p:nvPr>
-            <p:ph type="sldImg" idx="2"/>
-          </p:nvPr>
-        </p:nvSpPr>
-        <p:spPr>
-          <a:xfrm>
-            <a:off x="685800" y="1143000"/>
-            <a:ext cx="5486400" cy="3086100"/>
-          </a:xfrm>
-          <a:prstGeom prst="rect">
-            <a:avLst/>
-          </a:prstGeom>
-          <a:noFill/>
-          <a:ln w="12700">
-            <a:solidFill>
-              <a:prstClr val="black"/>
-            </a:solidFill>
-          </a:ln>
-        </p:spPr>
-        <p:txBody>
-          <a:bodyPr vert="horz" lIns="91440" tIns="45720" rIns="91440" bIns="45720" rtlCol="0" anchor="ctr"/>
-          <a:lstStyle/>
-          <a:p>
-            <a:endParaRPr lang="en-US"/>
-          </a:p>
-        </p:txBody>
-      </p:sp>
-      <p:sp>
-        <p:nvSpPr>
-          <p:cNvPr id="5" name="Notes Placeholder 4"/>
-          <p:cNvSpPr>
-            <a:spLocks noGrp="1"/>
-          </p:cNvSpPr>
-          <p:nvPr>
-            <p:ph type="body" sz="quarter" idx="3"/>
-          </p:nvPr>
-        </p:nvSpPr>
-        <p:spPr>
-          <a:xfrm>
-            <a:off x="685800" y="4400550"/>
-            <a:ext cx="5486400" cy="3600450"/>
-          </a:xfrm>
-          <a:prstGeom prst="rect">
-            <a:avLst/>
-          </a:prstGeom>
-        </p:spPr>
-        <p:txBody>
-          <a:bodyPr vert="horz" lIns="91440" tIns="45720" rIns="91440" bIns="45720" rtlCol="0"/>
-          <a:lstStyle/>
-          <a:p>
-            <a:pPr lvl="0"/>
-            <a:r>
-              <a:rPr lang="en-US"/>
-              <a:t>Click to edit Master text styles</a:t>
-            </a:r>
-          </a:p>
-          <a:p>
-            <a:pPr lvl="1"/>
-            <a:r>
-              <a:rPr lang="en-US"/>
-              <a:t>Second level</a:t>
-            </a:r>
-          </a:p>
-          <a:p>
-            <a:pPr lvl="2"/>
-            <a:r>
-              <a:rPr lang="en-US"/>
-              <a:t>Third level</a:t>
-            </a:r>
-          </a:p>
-          <a:p>
-            <a:pPr lvl="3"/>
-            <a:r>
-              <a:rPr lang="en-US"/>
-              <a:t>Fourth level</a:t>
-            </a:r>
-          </a:p>
-          <a:p>
-            <a:pPr lvl="4"/>
-            <a:r>
-              <a:rPr lang="en-US"/>
-              <a:t>Fifth level</a:t>
-            </a:r>
-          </a:p>
-        </p:txBody>
-      </p:sp>
-      <p:sp>
-        <p:nvSpPr>
-          <p:cNvPr id="6" name="Footer Placeholder 5"/>
-          <p:cNvSpPr>
-            <a:spLocks noGrp="1"/>
-          </p:cNvSpPr>
-          <p:nvPr>
-            <p:ph type="ftr" sz="quarter" idx="4"/>
-          </p:nvPr>
-        </p:nvSpPr>
-        <p:spPr>
-          <a:xfrm>
-            <a:off x="0" y="8685213"/>
-            <a:ext cx="2971800" cy="458787"/>
-          </a:xfrm>
-          <a:prstGeom prst="rect">
-            <a:avLst/>
-          </a:prstGeom>
-        </p:spPr>
-        <p:txBody>
-          <a:bodyPr vert="horz" lIns="91440" tIns="45720" rIns="91440" bIns="45720" rtlCol="0" anchor="b"/>
-          <a:lstStyle>
-            <a:lvl1pPr algn="l">
-              <a:defRPr sz="1200"/>
-            </a:lvl1pPr>
-          </a:lstStyle>
-          <a:p>
-            <a:endParaRPr lang="en-US"/>
-          </a:p>
-        </p:txBody>
-      </p:sp>
-      <p:sp>
-        <p:nvSpPr>
-          <p:cNvPr id="7" name="Slide Number Placeholder 6"/>
-          <p:cNvSpPr>
-            <a:spLocks noGrp="1"/>
-          </p:cNvSpPr>
-          <p:nvPr>
-            <p:ph type="sldNum" sz="quarter" idx="5"/>
-          </p:nvPr>
-        </p:nvSpPr>
-        <p:spPr>
-          <a:xfrm>
-            <a:off x="3884613" y="8685213"/>
-            <a:ext cx="2971800" cy="458787"/>
-          </a:xfrm>
-          <a:prstGeom prst="rect">
-            <a:avLst/>
-          </a:prstGeom>
-        </p:spPr>
-        <p:txBody>
-          <a:bodyPr vert="horz" lIns="91440" tIns="45720" rIns="91440" bIns="45720" rtlCol="0" anchor="b"/>
-          <a:lstStyle>
-            <a:lvl1pPr algn="r">
-              <a:defRPr sz="1200"/>
-            </a:lvl1pPr>
-          </a:lstStyle>
-          <a:p>
-            <a:fld id="{CE5E9CC1-C706-0F49-92D6-E571CC5EEA8F}" type="slidenum">
-              <a:rPr lang="en-US"/>
-              <a:t>‹#›</a:t>
-            </a:fld>
-            <a:endParaRPr lang="en-US"/>
-          </a:p>
-        </p:txBody>
-      </p:sp>
     </p:spTree>
     <p:extLst>
       <p:ext uri="{BB962C8B-B14F-4D97-AF65-F5344CB8AC3E}">
-        <p14:creationId xmlns:p14="http://schemas.microsoft.com/office/powerpoint/2010/main" val="1024086991"/>
+        <p14:creationId xmlns:p14="http://schemas.microsoft.com/office/powerpoint/2010/main" val="3479578009"/>
       </p:ext>
     </p:extLst>
   </p:cSld>
@@ -519,7 +300,6 @@
               <a:rPr lang="en-US" dirty="0"/>
               <a:t>Replace the bracketed placeholders with your names, course and date. Everything in this deck reflects what is actually built and tested as of the presentation date.</a:t>
             </a:r>
-            <a:endParaRPr lang="en-US" dirty="0"/>
           </a:p>
         </p:txBody>
       </p:sp>
@@ -603,10 +383,6 @@
           <a:bodyPr/>
           <a:lstStyle/>
           <a:p>
-            <a:r>
-              <a:rPr lang="en-US" dirty="0"/>
-              <a:t/>
-            </a:r>
             <a:endParaRPr lang="en-US" dirty="0"/>
           </a:p>
         </p:txBody>
@@ -691,10 +467,6 @@
           <a:bodyPr/>
           <a:lstStyle/>
           <a:p>
-            <a:r>
-              <a:rPr lang="en-US" dirty="0"/>
-              <a:t/>
-            </a:r>
             <a:endParaRPr lang="en-US" dirty="0"/>
           </a:p>
         </p:txBody>
@@ -779,10 +551,6 @@
           <a:bodyPr/>
           <a:lstStyle/>
           <a:p>
-            <a:r>
-              <a:rPr lang="en-US" dirty="0"/>
-              <a:t/>
-            </a:r>
             <a:endParaRPr lang="en-US" dirty="0"/>
           </a:p>
         </p:txBody>
@@ -867,10 +635,6 @@
           <a:bodyPr/>
           <a:lstStyle/>
           <a:p>
-            <a:r>
-              <a:rPr lang="en-US" dirty="0"/>
-              <a:t/>
-            </a:r>
             <a:endParaRPr lang="en-US" dirty="0"/>
           </a:p>
         </p:txBody>
@@ -955,10 +719,6 @@
           <a:bodyPr/>
           <a:lstStyle/>
           <a:p>
-            <a:r>
-              <a:rPr lang="en-US" dirty="0"/>
-              <a:t/>
-            </a:r>
             <a:endParaRPr lang="en-US" dirty="0"/>
           </a:p>
         </p:txBody>
@@ -1043,10 +803,6 @@
           <a:bodyPr/>
           <a:lstStyle/>
           <a:p>
-            <a:r>
-              <a:rPr lang="en-US" dirty="0"/>
-              <a:t/>
-            </a:r>
             <a:endParaRPr lang="en-US" dirty="0"/>
           </a:p>
         </p:txBody>
@@ -1131,10 +887,6 @@
           <a:bodyPr/>
           <a:lstStyle/>
           <a:p>
-            <a:r>
-              <a:rPr lang="en-US" dirty="0"/>
-              <a:t/>
-            </a:r>
             <a:endParaRPr lang="en-US" dirty="0"/>
           </a:p>
         </p:txBody>
@@ -1219,10 +971,6 @@
           <a:bodyPr/>
           <a:lstStyle/>
           <a:p>
-            <a:r>
-              <a:rPr lang="en-US" dirty="0"/>
-              <a:t/>
-            </a:r>
             <a:endParaRPr lang="en-US" dirty="0"/>
           </a:p>
         </p:txBody>
@@ -1307,10 +1055,6 @@
           <a:bodyPr/>
           <a:lstStyle/>
           <a:p>
-            <a:r>
-              <a:rPr lang="en-US" dirty="0"/>
-              <a:t/>
-            </a:r>
             <a:endParaRPr lang="en-US" dirty="0"/>
           </a:p>
         </p:txBody>
@@ -1395,10 +1139,6 @@
           <a:bodyPr/>
           <a:lstStyle/>
           <a:p>
-            <a:r>
-              <a:rPr lang="en-US" dirty="0"/>
-              <a:t/>
-            </a:r>
             <a:endParaRPr lang="en-US" dirty="0"/>
           </a:p>
         </p:txBody>
@@ -1483,10 +1223,6 @@
           <a:bodyPr/>
           <a:lstStyle/>
           <a:p>
-            <a:r>
-              <a:rPr lang="en-US" dirty="0"/>
-              <a:t/>
-            </a:r>
             <a:endParaRPr lang="en-US" dirty="0"/>
           </a:p>
         </p:txBody>
@@ -1571,10 +1307,6 @@
           <a:bodyPr/>
           <a:lstStyle/>
           <a:p>
-            <a:r>
-              <a:rPr lang="en-US" dirty="0"/>
-              <a:t/>
-            </a:r>
             <a:endParaRPr lang="en-US" dirty="0"/>
           </a:p>
         </p:txBody>
@@ -1659,10 +1391,6 @@
           <a:bodyPr/>
           <a:lstStyle/>
           <a:p>
-            <a:r>
-              <a:rPr lang="en-US" dirty="0"/>
-              <a:t/>
-            </a:r>
             <a:endParaRPr lang="en-US" dirty="0"/>
           </a:p>
         </p:txBody>
@@ -1747,10 +1475,6 @@
           <a:bodyPr/>
           <a:lstStyle/>
           <a:p>
-            <a:r>
-              <a:rPr lang="en-US" dirty="0"/>
-              <a:t/>
-            </a:r>
             <a:endParaRPr lang="en-US" dirty="0"/>
           </a:p>
         </p:txBody>
@@ -1835,10 +1559,6 @@
           <a:bodyPr/>
           <a:lstStyle/>
           <a:p>
-            <a:r>
-              <a:rPr lang="en-US" dirty="0"/>
-              <a:t/>
-            </a:r>
             <a:endParaRPr lang="en-US" dirty="0"/>
           </a:p>
         </p:txBody>
@@ -1912,6 +1632,11 @@
 <file path=ppt/slideMasters/slideMaster1.xml><?xml version="1.0" encoding="utf-8"?>
 <p:sldMaster xmlns:a="http://schemas.openxmlformats.org/drawingml/2006/main" xmlns:r="http://schemas.openxmlformats.org/officeDocument/2006/relationships" xmlns:p="http://schemas.openxmlformats.org/presentationml/2006/main">
   <p:cSld>
+    <p:bg>
+      <p:bgRef idx="1001">
+        <a:schemeClr val="bg1"/>
+      </p:bgRef>
+    </p:bg>
     <p:spTree>
       <p:nvGrpSpPr>
         <p:cNvPr id="1" name=""/>
@@ -2194,6 +1919,7 @@
         <a:solidFill>
           <a:srgbClr val="1B2430"/>
         </a:solidFill>
+        <a:effectLst/>
       </p:bgPr>
     </p:bg>
     <p:spTree>
@@ -2231,7 +1957,7 @@
           <a:bodyPr wrap="square" lIns="0" tIns="0" rIns="0" bIns="0" rtlCol="0" anchor="ctr"/>
           <a:lstStyle/>
           <a:p>
-            <a:pPr indent="0" marL="0">
+            <a:pPr marL="0" indent="0">
               <a:buNone/>
             </a:pPr>
             <a:r>
@@ -2270,7 +1996,7 @@
           <a:bodyPr wrap="square" lIns="0" tIns="0" rIns="0" bIns="0" rtlCol="0" anchor="ctr"/>
           <a:lstStyle/>
           <a:p>
-            <a:pPr indent="0" marL="0">
+            <a:pPr marL="0" indent="0">
               <a:buNone/>
             </a:pPr>
             <a:r>
@@ -2336,7 +2062,7 @@
           <a:bodyPr wrap="square" lIns="0" tIns="0" rIns="0" bIns="0" rtlCol="0" anchor="ctr"/>
           <a:lstStyle/>
           <a:p>
-            <a:pPr algn="ctr" indent="0" marL="0">
+            <a:pPr marL="0" indent="0" algn="ctr">
               <a:buNone/>
             </a:pPr>
             <a:r>
@@ -2375,7 +2101,7 @@
           <a:bodyPr wrap="square" lIns="0" tIns="0" rIns="0" bIns="0" rtlCol="0" anchor="ctr"/>
           <a:lstStyle/>
           <a:p>
-            <a:pPr indent="0" marL="0">
+            <a:pPr marL="0" indent="0">
               <a:buNone/>
             </a:pPr>
             <a:r>
@@ -2419,7 +2145,7 @@
             <a:prstDash val="solid"/>
           </a:ln>
           <a:effectLst>
-            <a:outerShdw sx="100000" sy="100000" kx="0" ky="0" algn="bl" rotWithShape="0" blurRad="101600" dist="38100" dir="5400000">
+            <a:outerShdw blurRad="101600" dist="38100" dir="5400000" algn="bl" rotWithShape="0">
               <a:srgbClr val="000000">
                 <a:alpha val="25000"/>
               </a:srgbClr>
@@ -2429,14 +2155,14 @@
       </p:sp>
       <p:pic>
         <p:nvPicPr>
-          <p:cNvPr id="8" name="Image 0" descr="C:/Users/ayush/Documents/PingHome/docs/screenshots/home_light.png">    </p:cNvPr>
+          <p:cNvPr id="8" name="Image 0" descr="C:/Users/ayush/Documents/PingHome/docs/screenshots/home_light.png"/>
           <p:cNvPicPr>
             <a:picLocks noChangeAspect="1"/>
           </p:cNvPicPr>
           <p:nvPr/>
         </p:nvPicPr>
         <p:blipFill>
-          <a:blip r:embed="rId1"/>
+          <a:blip r:embed="rId3"/>
           <a:stretch>
             <a:fillRect/>
           </a:stretch>
@@ -2467,6 +2193,7 @@
         <a:solidFill>
           <a:srgbClr val="F4F7FB"/>
         </a:solidFill>
+        <a:effectLst/>
       </p:bgPr>
     </p:bg>
     <p:spTree>
@@ -2504,7 +2231,7 @@
           <a:bodyPr wrap="square" lIns="0" tIns="0" rIns="0" bIns="0" rtlCol="0" anchor="ctr"/>
           <a:lstStyle/>
           <a:p>
-            <a:pPr indent="0" marL="0">
+            <a:pPr marL="0" indent="0">
               <a:buNone/>
             </a:pPr>
             <a:r>
@@ -2543,7 +2270,7 @@
           <a:bodyPr wrap="square" lIns="0" tIns="0" rIns="0" bIns="0" rtlCol="0" anchor="ctr"/>
           <a:lstStyle/>
           <a:p>
-            <a:pPr indent="0" marL="0">
+            <a:pPr marL="0" indent="0">
               <a:buNone/>
             </a:pPr>
             <a:r>
@@ -2582,7 +2309,7 @@
           <a:bodyPr wrap="square" lIns="0" tIns="0" rIns="0" bIns="0" rtlCol="0" anchor="ctr"/>
           <a:lstStyle/>
           <a:p>
-            <a:pPr algn="r" indent="0" marL="0">
+            <a:pPr marL="0" indent="0" algn="r">
               <a:buNone/>
             </a:pPr>
             <a:r>
@@ -2626,7 +2353,7 @@
             <a:prstDash val="solid"/>
           </a:ln>
           <a:effectLst>
-            <a:outerShdw sx="100000" sy="100000" kx="0" ky="0" algn="bl" rotWithShape="0" blurRad="101600" dist="38100" dir="5400000">
+            <a:outerShdw blurRad="101600" dist="38100" dir="5400000" algn="bl" rotWithShape="0">
               <a:srgbClr val="000000">
                 <a:alpha val="25000"/>
               </a:srgbClr>
@@ -2636,14 +2363,14 @@
       </p:sp>
       <p:pic>
         <p:nvPicPr>
-          <p:cNvPr id="6" name="Image 0" descr="C:/Users/ayush/Documents/PingHome/docs/screenshots/push_notification.png">    </p:cNvPr>
+          <p:cNvPr id="6" name="Image 0" descr="C:/Users/ayush/Documents/PingHome/docs/screenshots/push_notification.png"/>
           <p:cNvPicPr>
             <a:picLocks noChangeAspect="1"/>
           </p:cNvPicPr>
           <p:nvPr/>
         </p:nvPicPr>
         <p:blipFill>
-          <a:blip r:embed="rId1"/>
+          <a:blip r:embed="rId3"/>
           <a:stretch>
             <a:fillRect/>
           </a:stretch>
@@ -2679,7 +2406,7 @@
           <a:bodyPr wrap="square" lIns="0" tIns="0" rIns="0" bIns="0" rtlCol="0" anchor="ctr"/>
           <a:lstStyle/>
           <a:p>
-            <a:pPr algn="ctr" indent="0" marL="0">
+            <a:pPr marL="0" indent="0" algn="ctr">
               <a:buNone/>
             </a:pPr>
             <a:r>
@@ -2743,7 +2470,7 @@
           <a:bodyPr wrap="square" lIns="0" tIns="0" rIns="0" bIns="0" rtlCol="0" anchor="ctr"/>
           <a:lstStyle/>
           <a:p>
-            <a:pPr algn="ctr" indent="0" marL="0">
+            <a:pPr marL="0" indent="0" algn="ctr">
               <a:buNone/>
             </a:pPr>
             <a:r>
@@ -2782,7 +2509,7 @@
           <a:bodyPr wrap="square" lIns="0" tIns="0" rIns="0" bIns="0" rtlCol="0" anchor="t"/>
           <a:lstStyle/>
           <a:p>
-            <a:pPr indent="0" marL="0">
+            <a:pPr marL="0" indent="0">
               <a:buNone/>
             </a:pPr>
             <a:r>
@@ -2846,7 +2573,7 @@
           <a:bodyPr wrap="square" lIns="0" tIns="0" rIns="0" bIns="0" rtlCol="0" anchor="ctr"/>
           <a:lstStyle/>
           <a:p>
-            <a:pPr algn="ctr" indent="0" marL="0">
+            <a:pPr marL="0" indent="0" algn="ctr">
               <a:buNone/>
             </a:pPr>
             <a:r>
@@ -2885,7 +2612,7 @@
           <a:bodyPr wrap="square" lIns="0" tIns="0" rIns="0" bIns="0" rtlCol="0" anchor="t"/>
           <a:lstStyle/>
           <a:p>
-            <a:pPr indent="0" marL="0">
+            <a:pPr marL="0" indent="0">
               <a:buNone/>
             </a:pPr>
             <a:r>
@@ -2949,7 +2676,7 @@
           <a:bodyPr wrap="square" lIns="0" tIns="0" rIns="0" bIns="0" rtlCol="0" anchor="ctr"/>
           <a:lstStyle/>
           <a:p>
-            <a:pPr algn="ctr" indent="0" marL="0">
+            <a:pPr marL="0" indent="0" algn="ctr">
               <a:buNone/>
             </a:pPr>
             <a:r>
@@ -2988,7 +2715,7 @@
           <a:bodyPr wrap="square" lIns="0" tIns="0" rIns="0" bIns="0" rtlCol="0" anchor="t"/>
           <a:lstStyle/>
           <a:p>
-            <a:pPr indent="0" marL="0">
+            <a:pPr marL="0" indent="0">
               <a:buNone/>
             </a:pPr>
             <a:r>
@@ -3052,7 +2779,7 @@
           <a:bodyPr wrap="square" lIns="0" tIns="0" rIns="0" bIns="0" rtlCol="0" anchor="ctr"/>
           <a:lstStyle/>
           <a:p>
-            <a:pPr algn="ctr" indent="0" marL="0">
+            <a:pPr marL="0" indent="0" algn="ctr">
               <a:buNone/>
             </a:pPr>
             <a:r>
@@ -3091,7 +2818,7 @@
           <a:bodyPr wrap="square" lIns="0" tIns="0" rIns="0" bIns="0" rtlCol="0" anchor="t"/>
           <a:lstStyle/>
           <a:p>
-            <a:pPr indent="0" marL="0">
+            <a:pPr marL="0" indent="0">
               <a:buNone/>
             </a:pPr>
             <a:r>
@@ -3130,7 +2857,7 @@
           <a:bodyPr wrap="square" lIns="0" tIns="0" rIns="0" bIns="0" rtlCol="0" anchor="t"/>
           <a:lstStyle/>
           <a:p>
-            <a:pPr indent="0" marL="0">
+            <a:pPr marL="0" indent="0">
               <a:buNone/>
             </a:pPr>
             <a:r>
@@ -3164,6 +2891,7 @@
         <a:solidFill>
           <a:srgbClr val="F4F7FB"/>
         </a:solidFill>
+        <a:effectLst/>
       </p:bgPr>
     </p:bg>
     <p:spTree>
@@ -3201,7 +2929,7 @@
           <a:bodyPr wrap="square" lIns="0" tIns="0" rIns="0" bIns="0" rtlCol="0" anchor="ctr"/>
           <a:lstStyle/>
           <a:p>
-            <a:pPr indent="0" marL="0">
+            <a:pPr marL="0" indent="0">
               <a:buNone/>
             </a:pPr>
             <a:r>
@@ -3240,7 +2968,7 @@
           <a:bodyPr wrap="square" lIns="0" tIns="0" rIns="0" bIns="0" rtlCol="0" anchor="ctr"/>
           <a:lstStyle/>
           <a:p>
-            <a:pPr indent="0" marL="0">
+            <a:pPr marL="0" indent="0">
               <a:buNone/>
             </a:pPr>
             <a:r>
@@ -3279,7 +3007,7 @@
           <a:bodyPr wrap="square" lIns="0" tIns="0" rIns="0" bIns="0" rtlCol="0" anchor="ctr"/>
           <a:lstStyle/>
           <a:p>
-            <a:pPr algn="r" indent="0" marL="0">
+            <a:pPr marL="0" indent="0" algn="r">
               <a:buNone/>
             </a:pPr>
             <a:r>
@@ -3323,7 +3051,7 @@
             <a:prstDash val="solid"/>
           </a:ln>
           <a:effectLst>
-            <a:outerShdw sx="100000" sy="100000" kx="0" ky="0" algn="bl" rotWithShape="0" blurRad="76200" dist="25400" dir="5400000">
+            <a:outerShdw blurRad="76200" dist="25400" dir="5400000" algn="bl" rotWithShape="0">
               <a:srgbClr val="000000">
                 <a:alpha val="8000"/>
               </a:srgbClr>
@@ -3377,7 +3105,7 @@
           <a:bodyPr wrap="square" lIns="0" tIns="0" rIns="0" bIns="0" rtlCol="0" anchor="ctr"/>
           <a:lstStyle/>
           <a:p>
-            <a:pPr indent="0" marL="0">
+            <a:pPr marL="0" indent="0">
               <a:buNone/>
             </a:pPr>
             <a:r>
@@ -3416,7 +3144,7 @@
           <a:bodyPr wrap="square" lIns="0" tIns="0" rIns="0" bIns="0" rtlCol="0" anchor="ctr"/>
           <a:lstStyle/>
           <a:p>
-            <a:pPr indent="0" marL="0">
+            <a:pPr marL="0" indent="0">
               <a:buNone/>
             </a:pPr>
             <a:r>
@@ -3460,7 +3188,7 @@
             <a:prstDash val="solid"/>
           </a:ln>
           <a:effectLst>
-            <a:outerShdw sx="100000" sy="100000" kx="0" ky="0" algn="bl" rotWithShape="0" blurRad="76200" dist="25400" dir="5400000">
+            <a:outerShdw blurRad="76200" dist="25400" dir="5400000" algn="bl" rotWithShape="0">
               <a:srgbClr val="000000">
                 <a:alpha val="8000"/>
               </a:srgbClr>
@@ -3514,7 +3242,7 @@
           <a:bodyPr wrap="square" lIns="0" tIns="0" rIns="0" bIns="0" rtlCol="0" anchor="ctr"/>
           <a:lstStyle/>
           <a:p>
-            <a:pPr indent="0" marL="0">
+            <a:pPr marL="0" indent="0">
               <a:buNone/>
             </a:pPr>
             <a:r>
@@ -3553,7 +3281,7 @@
           <a:bodyPr wrap="square" lIns="0" tIns="0" rIns="0" bIns="0" rtlCol="0" anchor="ctr"/>
           <a:lstStyle/>
           <a:p>
-            <a:pPr indent="0" marL="0">
+            <a:pPr marL="0" indent="0">
               <a:buNone/>
             </a:pPr>
             <a:r>
@@ -3597,7 +3325,7 @@
             <a:prstDash val="solid"/>
           </a:ln>
           <a:effectLst>
-            <a:outerShdw sx="100000" sy="100000" kx="0" ky="0" algn="bl" rotWithShape="0" blurRad="76200" dist="25400" dir="5400000">
+            <a:outerShdw blurRad="76200" dist="25400" dir="5400000" algn="bl" rotWithShape="0">
               <a:srgbClr val="000000">
                 <a:alpha val="8000"/>
               </a:srgbClr>
@@ -3651,7 +3379,7 @@
           <a:bodyPr wrap="square" lIns="0" tIns="0" rIns="0" bIns="0" rtlCol="0" anchor="ctr"/>
           <a:lstStyle/>
           <a:p>
-            <a:pPr indent="0" marL="0">
+            <a:pPr marL="0" indent="0">
               <a:buNone/>
             </a:pPr>
             <a:r>
@@ -3690,7 +3418,7 @@
           <a:bodyPr wrap="square" lIns="0" tIns="0" rIns="0" bIns="0" rtlCol="0" anchor="ctr"/>
           <a:lstStyle/>
           <a:p>
-            <a:pPr indent="0" marL="0">
+            <a:pPr marL="0" indent="0">
               <a:buNone/>
             </a:pPr>
             <a:r>
@@ -3734,7 +3462,7 @@
             <a:prstDash val="solid"/>
           </a:ln>
           <a:effectLst>
-            <a:outerShdw sx="100000" sy="100000" kx="0" ky="0" algn="bl" rotWithShape="0" blurRad="76200" dist="25400" dir="5400000">
+            <a:outerShdw blurRad="76200" dist="25400" dir="5400000" algn="bl" rotWithShape="0">
               <a:srgbClr val="000000">
                 <a:alpha val="8000"/>
               </a:srgbClr>
@@ -3788,7 +3516,7 @@
           <a:bodyPr wrap="square" lIns="0" tIns="0" rIns="0" bIns="0" rtlCol="0" anchor="ctr"/>
           <a:lstStyle/>
           <a:p>
-            <a:pPr indent="0" marL="0">
+            <a:pPr marL="0" indent="0">
               <a:buNone/>
             </a:pPr>
             <a:r>
@@ -3827,7 +3555,7 @@
           <a:bodyPr wrap="square" lIns="0" tIns="0" rIns="0" bIns="0" rtlCol="0" anchor="ctr"/>
           <a:lstStyle/>
           <a:p>
-            <a:pPr indent="0" marL="0">
+            <a:pPr marL="0" indent="0">
               <a:buNone/>
             </a:pPr>
             <a:r>
@@ -3871,7 +3599,7 @@
             <a:prstDash val="solid"/>
           </a:ln>
           <a:effectLst>
-            <a:outerShdw sx="100000" sy="100000" kx="0" ky="0" algn="bl" rotWithShape="0" blurRad="76200" dist="25400" dir="5400000">
+            <a:outerShdw blurRad="76200" dist="25400" dir="5400000" algn="bl" rotWithShape="0">
               <a:srgbClr val="000000">
                 <a:alpha val="8000"/>
               </a:srgbClr>
@@ -3925,7 +3653,7 @@
           <a:bodyPr wrap="square" lIns="0" tIns="0" rIns="0" bIns="0" rtlCol="0" anchor="ctr"/>
           <a:lstStyle/>
           <a:p>
-            <a:pPr indent="0" marL="0">
+            <a:pPr marL="0" indent="0">
               <a:buNone/>
             </a:pPr>
             <a:r>
@@ -3964,7 +3692,7 @@
           <a:bodyPr wrap="square" lIns="0" tIns="0" rIns="0" bIns="0" rtlCol="0" anchor="ctr"/>
           <a:lstStyle/>
           <a:p>
-            <a:pPr indent="0" marL="0">
+            <a:pPr marL="0" indent="0">
               <a:buNone/>
             </a:pPr>
             <a:r>
@@ -3998,6 +3726,7 @@
         <a:solidFill>
           <a:srgbClr val="F4F7FB"/>
         </a:solidFill>
+        <a:effectLst/>
       </p:bgPr>
     </p:bg>
     <p:spTree>
@@ -4035,7 +3764,7 @@
           <a:bodyPr wrap="square" lIns="0" tIns="0" rIns="0" bIns="0" rtlCol="0" anchor="ctr"/>
           <a:lstStyle/>
           <a:p>
-            <a:pPr indent="0" marL="0">
+            <a:pPr marL="0" indent="0">
               <a:buNone/>
             </a:pPr>
             <a:r>
@@ -4074,7 +3803,7 @@
           <a:bodyPr wrap="square" lIns="0" tIns="0" rIns="0" bIns="0" rtlCol="0" anchor="ctr"/>
           <a:lstStyle/>
           <a:p>
-            <a:pPr indent="0" marL="0">
+            <a:pPr marL="0" indent="0">
               <a:buNone/>
             </a:pPr>
             <a:r>
@@ -4113,7 +3842,7 @@
           <a:bodyPr wrap="square" lIns="0" tIns="0" rIns="0" bIns="0" rtlCol="0" anchor="ctr"/>
           <a:lstStyle/>
           <a:p>
-            <a:pPr algn="r" indent="0" marL="0">
+            <a:pPr marL="0" indent="0" algn="r">
               <a:buNone/>
             </a:pPr>
             <a:r>
@@ -4147,16 +3876,34 @@
         </p:nvGraphicFramePr>
         <p:xfrm>
           <a:off x="457200" y="1234440"/>
-          <a:ext cx="8229600" cy="914400"/>
+          <a:ext cx="8229600" cy="3319272"/>
         </p:xfrm>
         <a:graphic>
           <a:graphicData uri="http://schemas.openxmlformats.org/drawingml/2006/table">
             <a:tbl>
               <a:tblPr/>
               <a:tblGrid>
-                <a:gridCol w="365760"/>
-                <a:gridCol w="3291840"/>
-                <a:gridCol w="4572000"/>
+                <a:gridCol w="365760">
+                  <a:extLst>
+                    <a:ext uri="{9D8B030D-6E8A-4147-A177-3AD203B41FA5}">
+                      <a16:colId xmlns:a16="http://schemas.microsoft.com/office/drawing/2014/main" val="20000"/>
+                    </a:ext>
+                  </a:extLst>
+                </a:gridCol>
+                <a:gridCol w="3291840">
+                  <a:extLst>
+                    <a:ext uri="{9D8B030D-6E8A-4147-A177-3AD203B41FA5}">
+                      <a16:colId xmlns:a16="http://schemas.microsoft.com/office/drawing/2014/main" val="20001"/>
+                    </a:ext>
+                  </a:extLst>
+                </a:gridCol>
+                <a:gridCol w="4572000">
+                  <a:extLst>
+                    <a:ext uri="{9D8B030D-6E8A-4147-A177-3AD203B41FA5}">
+                      <a16:colId xmlns:a16="http://schemas.microsoft.com/office/drawing/2014/main" val="20002"/>
+                    </a:ext>
+                  </a:extLst>
+                </a:gridCol>
               </a:tblGrid>
               <a:tr h="301752">
                 <a:tc>
@@ -4164,7 +3911,7 @@
                     <a:bodyPr/>
                     <a:lstStyle/>
                     <a:p>
-                      <a:pPr indent="0" marL="0">
+                      <a:pPr marL="0" indent="0">
                         <a:buNone/>
                       </a:pPr>
                       <a:r>
@@ -4185,7 +3932,7 @@
                       </a:endParaRPr>
                     </a:p>
                   </a:txBody>
-                  <a:tcPr marL="45720" marR="45720" marT="45720" marB="45720">
+                  <a:tcPr marL="45720" marR="45720">
                     <a:lnL w="12700" cap="flat" cmpd="sng" algn="ctr">
                       <a:solidFill>
                         <a:srgbClr val="F4F7FB"/>
@@ -4232,7 +3979,7 @@
                     <a:bodyPr/>
                     <a:lstStyle/>
                     <a:p>
-                      <a:pPr indent="0" marL="0">
+                      <a:pPr marL="0" indent="0">
                         <a:buNone/>
                       </a:pPr>
                       <a:r>
@@ -4253,7 +4000,7 @@
                       </a:endParaRPr>
                     </a:p>
                   </a:txBody>
-                  <a:tcPr marL="45720" marR="45720" marT="45720" marB="45720">
+                  <a:tcPr marL="45720" marR="45720">
                     <a:lnL w="12700" cap="flat" cmpd="sng" algn="ctr">
                       <a:solidFill>
                         <a:srgbClr val="F4F7FB"/>
@@ -4300,7 +4047,7 @@
                     <a:bodyPr/>
                     <a:lstStyle/>
                     <a:p>
-                      <a:pPr indent="0" marL="0">
+                      <a:pPr marL="0" indent="0">
                         <a:buNone/>
                       </a:pPr>
                       <a:r>
@@ -4321,7 +4068,7 @@
                       </a:endParaRPr>
                     </a:p>
                   </a:txBody>
-                  <a:tcPr marL="45720" marR="45720" marT="45720" marB="45720">
+                  <a:tcPr marL="45720" marR="45720">
                     <a:lnL w="12700" cap="flat" cmpd="sng" algn="ctr">
                       <a:solidFill>
                         <a:srgbClr val="F4F7FB"/>
@@ -4363,6 +4110,11 @@
                     </a:solidFill>
                   </a:tcPr>
                 </a:tc>
+                <a:extLst>
+                  <a:ext uri="{0D108BD9-81ED-4DB2-BD59-A6C34878D82A}">
+                    <a16:rowId xmlns:a16="http://schemas.microsoft.com/office/drawing/2014/main" val="10000"/>
+                  </a:ext>
+                </a:extLst>
               </a:tr>
               <a:tr h="301752">
                 <a:tc>
@@ -4370,7 +4122,7 @@
                     <a:bodyPr/>
                     <a:lstStyle/>
                     <a:p>
-                      <a:pPr indent="0" marL="0">
+                      <a:pPr marL="0" indent="0">
                         <a:buNone/>
                       </a:pPr>
                       <a:r>
@@ -4391,7 +4143,7 @@
                       </a:endParaRPr>
                     </a:p>
                   </a:txBody>
-                  <a:tcPr marL="45720" marR="45720" marT="45720" marB="45720">
+                  <a:tcPr marL="45720" marR="45720">
                     <a:lnL w="12700" cap="flat" cmpd="sng" algn="ctr">
                       <a:solidFill>
                         <a:srgbClr val="F4F7FB"/>
@@ -4438,7 +4190,7 @@
                     <a:bodyPr/>
                     <a:lstStyle/>
                     <a:p>
-                      <a:pPr indent="0" marL="0">
+                      <a:pPr marL="0" indent="0">
                         <a:buNone/>
                       </a:pPr>
                       <a:r>
@@ -4459,7 +4211,7 @@
                       </a:endParaRPr>
                     </a:p>
                   </a:txBody>
-                  <a:tcPr marL="45720" marR="45720" marT="45720" marB="45720">
+                  <a:tcPr marL="45720" marR="45720">
                     <a:lnL w="12700" cap="flat" cmpd="sng" algn="ctr">
                       <a:solidFill>
                         <a:srgbClr val="F4F7FB"/>
@@ -4506,7 +4258,7 @@
                     <a:bodyPr/>
                     <a:lstStyle/>
                     <a:p>
-                      <a:pPr indent="0" marL="0">
+                      <a:pPr marL="0" indent="0">
                         <a:buNone/>
                       </a:pPr>
                       <a:r>
@@ -4527,7 +4279,7 @@
                       </a:endParaRPr>
                     </a:p>
                   </a:txBody>
-                  <a:tcPr marL="45720" marR="45720" marT="45720" marB="45720">
+                  <a:tcPr marL="45720" marR="45720">
                     <a:lnL w="12700" cap="flat" cmpd="sng" algn="ctr">
                       <a:solidFill>
                         <a:srgbClr val="F4F7FB"/>
@@ -4569,6 +4321,11 @@
                     </a:solidFill>
                   </a:tcPr>
                 </a:tc>
+                <a:extLst>
+                  <a:ext uri="{0D108BD9-81ED-4DB2-BD59-A6C34878D82A}">
+                    <a16:rowId xmlns:a16="http://schemas.microsoft.com/office/drawing/2014/main" val="10001"/>
+                  </a:ext>
+                </a:extLst>
               </a:tr>
               <a:tr h="301752">
                 <a:tc>
@@ -4576,7 +4333,7 @@
                     <a:bodyPr/>
                     <a:lstStyle/>
                     <a:p>
-                      <a:pPr indent="0" marL="0">
+                      <a:pPr marL="0" indent="0">
                         <a:buNone/>
                       </a:pPr>
                       <a:r>
@@ -4597,7 +4354,7 @@
                       </a:endParaRPr>
                     </a:p>
                   </a:txBody>
-                  <a:tcPr marL="45720" marR="45720" marT="45720" marB="45720">
+                  <a:tcPr marL="45720" marR="45720">
                     <a:lnL w="12700" cap="flat" cmpd="sng" algn="ctr">
                       <a:solidFill>
                         <a:srgbClr val="F4F7FB"/>
@@ -4644,7 +4401,7 @@
                     <a:bodyPr/>
                     <a:lstStyle/>
                     <a:p>
-                      <a:pPr indent="0" marL="0">
+                      <a:pPr marL="0" indent="0">
                         <a:buNone/>
                       </a:pPr>
                       <a:r>
@@ -4665,7 +4422,7 @@
                       </a:endParaRPr>
                     </a:p>
                   </a:txBody>
-                  <a:tcPr marL="45720" marR="45720" marT="45720" marB="45720">
+                  <a:tcPr marL="45720" marR="45720">
                     <a:lnL w="12700" cap="flat" cmpd="sng" algn="ctr">
                       <a:solidFill>
                         <a:srgbClr val="F4F7FB"/>
@@ -4712,7 +4469,7 @@
                     <a:bodyPr/>
                     <a:lstStyle/>
                     <a:p>
-                      <a:pPr indent="0" marL="0">
+                      <a:pPr marL="0" indent="0">
                         <a:buNone/>
                       </a:pPr>
                       <a:r>
@@ -4733,7 +4490,7 @@
                       </a:endParaRPr>
                     </a:p>
                   </a:txBody>
-                  <a:tcPr marL="45720" marR="45720" marT="45720" marB="45720">
+                  <a:tcPr marL="45720" marR="45720">
                     <a:lnL w="12700" cap="flat" cmpd="sng" algn="ctr">
                       <a:solidFill>
                         <a:srgbClr val="F4F7FB"/>
@@ -4775,6 +4532,11 @@
                     </a:solidFill>
                   </a:tcPr>
                 </a:tc>
+                <a:extLst>
+                  <a:ext uri="{0D108BD9-81ED-4DB2-BD59-A6C34878D82A}">
+                    <a16:rowId xmlns:a16="http://schemas.microsoft.com/office/drawing/2014/main" val="10002"/>
+                  </a:ext>
+                </a:extLst>
               </a:tr>
               <a:tr h="301752">
                 <a:tc>
@@ -4782,7 +4544,7 @@
                     <a:bodyPr/>
                     <a:lstStyle/>
                     <a:p>
-                      <a:pPr indent="0" marL="0">
+                      <a:pPr marL="0" indent="0">
                         <a:buNone/>
                       </a:pPr>
                       <a:r>
@@ -4803,7 +4565,7 @@
                       </a:endParaRPr>
                     </a:p>
                   </a:txBody>
-                  <a:tcPr marL="45720" marR="45720" marT="45720" marB="45720">
+                  <a:tcPr marL="45720" marR="45720">
                     <a:lnL w="12700" cap="flat" cmpd="sng" algn="ctr">
                       <a:solidFill>
                         <a:srgbClr val="F4F7FB"/>
@@ -4850,7 +4612,7 @@
                     <a:bodyPr/>
                     <a:lstStyle/>
                     <a:p>
-                      <a:pPr indent="0" marL="0">
+                      <a:pPr marL="0" indent="0">
                         <a:buNone/>
                       </a:pPr>
                       <a:r>
@@ -4871,7 +4633,7 @@
                       </a:endParaRPr>
                     </a:p>
                   </a:txBody>
-                  <a:tcPr marL="45720" marR="45720" marT="45720" marB="45720">
+                  <a:tcPr marL="45720" marR="45720">
                     <a:lnL w="12700" cap="flat" cmpd="sng" algn="ctr">
                       <a:solidFill>
                         <a:srgbClr val="F4F7FB"/>
@@ -4918,7 +4680,7 @@
                     <a:bodyPr/>
                     <a:lstStyle/>
                     <a:p>
-                      <a:pPr indent="0" marL="0">
+                      <a:pPr marL="0" indent="0">
                         <a:buNone/>
                       </a:pPr>
                       <a:r>
@@ -4939,7 +4701,7 @@
                       </a:endParaRPr>
                     </a:p>
                   </a:txBody>
-                  <a:tcPr marL="45720" marR="45720" marT="45720" marB="45720">
+                  <a:tcPr marL="45720" marR="45720">
                     <a:lnL w="12700" cap="flat" cmpd="sng" algn="ctr">
                       <a:solidFill>
                         <a:srgbClr val="F4F7FB"/>
@@ -4981,6 +4743,11 @@
                     </a:solidFill>
                   </a:tcPr>
                 </a:tc>
+                <a:extLst>
+                  <a:ext uri="{0D108BD9-81ED-4DB2-BD59-A6C34878D82A}">
+                    <a16:rowId xmlns:a16="http://schemas.microsoft.com/office/drawing/2014/main" val="10003"/>
+                  </a:ext>
+                </a:extLst>
               </a:tr>
               <a:tr h="301752">
                 <a:tc>
@@ -4988,7 +4755,7 @@
                     <a:bodyPr/>
                     <a:lstStyle/>
                     <a:p>
-                      <a:pPr indent="0" marL="0">
+                      <a:pPr marL="0" indent="0">
                         <a:buNone/>
                       </a:pPr>
                       <a:r>
@@ -5009,7 +4776,7 @@
                       </a:endParaRPr>
                     </a:p>
                   </a:txBody>
-                  <a:tcPr marL="45720" marR="45720" marT="45720" marB="45720">
+                  <a:tcPr marL="45720" marR="45720">
                     <a:lnL w="12700" cap="flat" cmpd="sng" algn="ctr">
                       <a:solidFill>
                         <a:srgbClr val="F4F7FB"/>
@@ -5056,7 +4823,7 @@
                     <a:bodyPr/>
                     <a:lstStyle/>
                     <a:p>
-                      <a:pPr indent="0" marL="0">
+                      <a:pPr marL="0" indent="0">
                         <a:buNone/>
                       </a:pPr>
                       <a:r>
@@ -5077,7 +4844,7 @@
                       </a:endParaRPr>
                     </a:p>
                   </a:txBody>
-                  <a:tcPr marL="45720" marR="45720" marT="45720" marB="45720">
+                  <a:tcPr marL="45720" marR="45720">
                     <a:lnL w="12700" cap="flat" cmpd="sng" algn="ctr">
                       <a:solidFill>
                         <a:srgbClr val="F4F7FB"/>
@@ -5124,7 +4891,7 @@
                     <a:bodyPr/>
                     <a:lstStyle/>
                     <a:p>
-                      <a:pPr indent="0" marL="0">
+                      <a:pPr marL="0" indent="0">
                         <a:buNone/>
                       </a:pPr>
                       <a:r>
@@ -5145,7 +4912,7 @@
                       </a:endParaRPr>
                     </a:p>
                   </a:txBody>
-                  <a:tcPr marL="45720" marR="45720" marT="45720" marB="45720">
+                  <a:tcPr marL="45720" marR="45720">
                     <a:lnL w="12700" cap="flat" cmpd="sng" algn="ctr">
                       <a:solidFill>
                         <a:srgbClr val="F4F7FB"/>
@@ -5187,6 +4954,11 @@
                     </a:solidFill>
                   </a:tcPr>
                 </a:tc>
+                <a:extLst>
+                  <a:ext uri="{0D108BD9-81ED-4DB2-BD59-A6C34878D82A}">
+                    <a16:rowId xmlns:a16="http://schemas.microsoft.com/office/drawing/2014/main" val="10004"/>
+                  </a:ext>
+                </a:extLst>
               </a:tr>
               <a:tr h="301752">
                 <a:tc>
@@ -5194,7 +4966,7 @@
                     <a:bodyPr/>
                     <a:lstStyle/>
                     <a:p>
-                      <a:pPr indent="0" marL="0">
+                      <a:pPr marL="0" indent="0">
                         <a:buNone/>
                       </a:pPr>
                       <a:r>
@@ -5215,7 +4987,7 @@
                       </a:endParaRPr>
                     </a:p>
                   </a:txBody>
-                  <a:tcPr marL="45720" marR="45720" marT="45720" marB="45720">
+                  <a:tcPr marL="45720" marR="45720">
                     <a:lnL w="12700" cap="flat" cmpd="sng" algn="ctr">
                       <a:solidFill>
                         <a:srgbClr val="F4F7FB"/>
@@ -5262,7 +5034,7 @@
                     <a:bodyPr/>
                     <a:lstStyle/>
                     <a:p>
-                      <a:pPr indent="0" marL="0">
+                      <a:pPr marL="0" indent="0">
                         <a:buNone/>
                       </a:pPr>
                       <a:r>
@@ -5283,7 +5055,7 @@
                       </a:endParaRPr>
                     </a:p>
                   </a:txBody>
-                  <a:tcPr marL="45720" marR="45720" marT="45720" marB="45720">
+                  <a:tcPr marL="45720" marR="45720">
                     <a:lnL w="12700" cap="flat" cmpd="sng" algn="ctr">
                       <a:solidFill>
                         <a:srgbClr val="F4F7FB"/>
@@ -5330,7 +5102,7 @@
                     <a:bodyPr/>
                     <a:lstStyle/>
                     <a:p>
-                      <a:pPr indent="0" marL="0">
+                      <a:pPr marL="0" indent="0">
                         <a:buNone/>
                       </a:pPr>
                       <a:r>
@@ -5351,7 +5123,7 @@
                       </a:endParaRPr>
                     </a:p>
                   </a:txBody>
-                  <a:tcPr marL="45720" marR="45720" marT="45720" marB="45720">
+                  <a:tcPr marL="45720" marR="45720">
                     <a:lnL w="12700" cap="flat" cmpd="sng" algn="ctr">
                       <a:solidFill>
                         <a:srgbClr val="F4F7FB"/>
@@ -5393,6 +5165,11 @@
                     </a:solidFill>
                   </a:tcPr>
                 </a:tc>
+                <a:extLst>
+                  <a:ext uri="{0D108BD9-81ED-4DB2-BD59-A6C34878D82A}">
+                    <a16:rowId xmlns:a16="http://schemas.microsoft.com/office/drawing/2014/main" val="10005"/>
+                  </a:ext>
+                </a:extLst>
               </a:tr>
               <a:tr h="301752">
                 <a:tc>
@@ -5400,7 +5177,7 @@
                     <a:bodyPr/>
                     <a:lstStyle/>
                     <a:p>
-                      <a:pPr indent="0" marL="0">
+                      <a:pPr marL="0" indent="0">
                         <a:buNone/>
                       </a:pPr>
                       <a:r>
@@ -5421,7 +5198,7 @@
                       </a:endParaRPr>
                     </a:p>
                   </a:txBody>
-                  <a:tcPr marL="45720" marR="45720" marT="45720" marB="45720">
+                  <a:tcPr marL="45720" marR="45720">
                     <a:lnL w="12700" cap="flat" cmpd="sng" algn="ctr">
                       <a:solidFill>
                         <a:srgbClr val="F4F7FB"/>
@@ -5468,7 +5245,7 @@
                     <a:bodyPr/>
                     <a:lstStyle/>
                     <a:p>
-                      <a:pPr indent="0" marL="0">
+                      <a:pPr marL="0" indent="0">
                         <a:buNone/>
                       </a:pPr>
                       <a:r>
@@ -5489,7 +5266,7 @@
                       </a:endParaRPr>
                     </a:p>
                   </a:txBody>
-                  <a:tcPr marL="45720" marR="45720" marT="45720" marB="45720">
+                  <a:tcPr marL="45720" marR="45720">
                     <a:lnL w="12700" cap="flat" cmpd="sng" algn="ctr">
                       <a:solidFill>
                         <a:srgbClr val="F4F7FB"/>
@@ -5536,7 +5313,7 @@
                     <a:bodyPr/>
                     <a:lstStyle/>
                     <a:p>
-                      <a:pPr indent="0" marL="0">
+                      <a:pPr marL="0" indent="0">
                         <a:buNone/>
                       </a:pPr>
                       <a:r>
@@ -5557,7 +5334,7 @@
                       </a:endParaRPr>
                     </a:p>
                   </a:txBody>
-                  <a:tcPr marL="45720" marR="45720" marT="45720" marB="45720">
+                  <a:tcPr marL="45720" marR="45720">
                     <a:lnL w="12700" cap="flat" cmpd="sng" algn="ctr">
                       <a:solidFill>
                         <a:srgbClr val="F4F7FB"/>
@@ -5599,6 +5376,11 @@
                     </a:solidFill>
                   </a:tcPr>
                 </a:tc>
+                <a:extLst>
+                  <a:ext uri="{0D108BD9-81ED-4DB2-BD59-A6C34878D82A}">
+                    <a16:rowId xmlns:a16="http://schemas.microsoft.com/office/drawing/2014/main" val="10006"/>
+                  </a:ext>
+                </a:extLst>
               </a:tr>
               <a:tr h="301752">
                 <a:tc>
@@ -5606,7 +5388,7 @@
                     <a:bodyPr/>
                     <a:lstStyle/>
                     <a:p>
-                      <a:pPr indent="0" marL="0">
+                      <a:pPr marL="0" indent="0">
                         <a:buNone/>
                       </a:pPr>
                       <a:r>
@@ -5627,7 +5409,7 @@
                       </a:endParaRPr>
                     </a:p>
                   </a:txBody>
-                  <a:tcPr marL="45720" marR="45720" marT="45720" marB="45720">
+                  <a:tcPr marL="45720" marR="45720">
                     <a:lnL w="12700" cap="flat" cmpd="sng" algn="ctr">
                       <a:solidFill>
                         <a:srgbClr val="F4F7FB"/>
@@ -5674,7 +5456,7 @@
                     <a:bodyPr/>
                     <a:lstStyle/>
                     <a:p>
-                      <a:pPr indent="0" marL="0">
+                      <a:pPr marL="0" indent="0">
                         <a:buNone/>
                       </a:pPr>
                       <a:r>
@@ -5695,7 +5477,7 @@
                       </a:endParaRPr>
                     </a:p>
                   </a:txBody>
-                  <a:tcPr marL="45720" marR="45720" marT="45720" marB="45720">
+                  <a:tcPr marL="45720" marR="45720">
                     <a:lnL w="12700" cap="flat" cmpd="sng" algn="ctr">
                       <a:solidFill>
                         <a:srgbClr val="F4F7FB"/>
@@ -5742,7 +5524,7 @@
                     <a:bodyPr/>
                     <a:lstStyle/>
                     <a:p>
-                      <a:pPr indent="0" marL="0">
+                      <a:pPr marL="0" indent="0">
                         <a:buNone/>
                       </a:pPr>
                       <a:r>
@@ -5763,7 +5545,7 @@
                       </a:endParaRPr>
                     </a:p>
                   </a:txBody>
-                  <a:tcPr marL="45720" marR="45720" marT="45720" marB="45720">
+                  <a:tcPr marL="45720" marR="45720">
                     <a:lnL w="12700" cap="flat" cmpd="sng" algn="ctr">
                       <a:solidFill>
                         <a:srgbClr val="F4F7FB"/>
@@ -5805,6 +5587,11 @@
                     </a:solidFill>
                   </a:tcPr>
                 </a:tc>
+                <a:extLst>
+                  <a:ext uri="{0D108BD9-81ED-4DB2-BD59-A6C34878D82A}">
+                    <a16:rowId xmlns:a16="http://schemas.microsoft.com/office/drawing/2014/main" val="10007"/>
+                  </a:ext>
+                </a:extLst>
               </a:tr>
               <a:tr h="301752">
                 <a:tc>
@@ -5812,7 +5599,7 @@
                     <a:bodyPr/>
                     <a:lstStyle/>
                     <a:p>
-                      <a:pPr indent="0" marL="0">
+                      <a:pPr marL="0" indent="0">
                         <a:buNone/>
                       </a:pPr>
                       <a:r>
@@ -5833,7 +5620,7 @@
                       </a:endParaRPr>
                     </a:p>
                   </a:txBody>
-                  <a:tcPr marL="45720" marR="45720" marT="45720" marB="45720">
+                  <a:tcPr marL="45720" marR="45720">
                     <a:lnL w="12700" cap="flat" cmpd="sng" algn="ctr">
                       <a:solidFill>
                         <a:srgbClr val="F4F7FB"/>
@@ -5880,7 +5667,7 @@
                     <a:bodyPr/>
                     <a:lstStyle/>
                     <a:p>
-                      <a:pPr indent="0" marL="0">
+                      <a:pPr marL="0" indent="0">
                         <a:buNone/>
                       </a:pPr>
                       <a:r>
@@ -5901,7 +5688,7 @@
                       </a:endParaRPr>
                     </a:p>
                   </a:txBody>
-                  <a:tcPr marL="45720" marR="45720" marT="45720" marB="45720">
+                  <a:tcPr marL="45720" marR="45720">
                     <a:lnL w="12700" cap="flat" cmpd="sng" algn="ctr">
                       <a:solidFill>
                         <a:srgbClr val="F4F7FB"/>
@@ -5948,7 +5735,7 @@
                     <a:bodyPr/>
                     <a:lstStyle/>
                     <a:p>
-                      <a:pPr indent="0" marL="0">
+                      <a:pPr marL="0" indent="0">
                         <a:buNone/>
                       </a:pPr>
                       <a:r>
@@ -5969,7 +5756,7 @@
                       </a:endParaRPr>
                     </a:p>
                   </a:txBody>
-                  <a:tcPr marL="45720" marR="45720" marT="45720" marB="45720">
+                  <a:tcPr marL="45720" marR="45720">
                     <a:lnL w="12700" cap="flat" cmpd="sng" algn="ctr">
                       <a:solidFill>
                         <a:srgbClr val="F4F7FB"/>
@@ -6011,6 +5798,11 @@
                     </a:solidFill>
                   </a:tcPr>
                 </a:tc>
+                <a:extLst>
+                  <a:ext uri="{0D108BD9-81ED-4DB2-BD59-A6C34878D82A}">
+                    <a16:rowId xmlns:a16="http://schemas.microsoft.com/office/drawing/2014/main" val="10008"/>
+                  </a:ext>
+                </a:extLst>
               </a:tr>
               <a:tr h="301752">
                 <a:tc>
@@ -6018,7 +5810,7 @@
                     <a:bodyPr/>
                     <a:lstStyle/>
                     <a:p>
-                      <a:pPr indent="0" marL="0">
+                      <a:pPr marL="0" indent="0">
                         <a:buNone/>
                       </a:pPr>
                       <a:r>
@@ -6039,7 +5831,7 @@
                       </a:endParaRPr>
                     </a:p>
                   </a:txBody>
-                  <a:tcPr marL="45720" marR="45720" marT="45720" marB="45720">
+                  <a:tcPr marL="45720" marR="45720">
                     <a:lnL w="12700" cap="flat" cmpd="sng" algn="ctr">
                       <a:solidFill>
                         <a:srgbClr val="F4F7FB"/>
@@ -6086,7 +5878,7 @@
                     <a:bodyPr/>
                     <a:lstStyle/>
                     <a:p>
-                      <a:pPr indent="0" marL="0">
+                      <a:pPr marL="0" indent="0">
                         <a:buNone/>
                       </a:pPr>
                       <a:r>
@@ -6107,7 +5899,7 @@
                       </a:endParaRPr>
                     </a:p>
                   </a:txBody>
-                  <a:tcPr marL="45720" marR="45720" marT="45720" marB="45720">
+                  <a:tcPr marL="45720" marR="45720">
                     <a:lnL w="12700" cap="flat" cmpd="sng" algn="ctr">
                       <a:solidFill>
                         <a:srgbClr val="F4F7FB"/>
@@ -6154,7 +5946,7 @@
                     <a:bodyPr/>
                     <a:lstStyle/>
                     <a:p>
-                      <a:pPr indent="0" marL="0">
+                      <a:pPr marL="0" indent="0">
                         <a:buNone/>
                       </a:pPr>
                       <a:r>
@@ -6175,7 +5967,7 @@
                       </a:endParaRPr>
                     </a:p>
                   </a:txBody>
-                  <a:tcPr marL="45720" marR="45720" marT="45720" marB="45720">
+                  <a:tcPr marL="45720" marR="45720">
                     <a:lnL w="12700" cap="flat" cmpd="sng" algn="ctr">
                       <a:solidFill>
                         <a:srgbClr val="F4F7FB"/>
@@ -6217,6 +6009,11 @@
                     </a:solidFill>
                   </a:tcPr>
                 </a:tc>
+                <a:extLst>
+                  <a:ext uri="{0D108BD9-81ED-4DB2-BD59-A6C34878D82A}">
+                    <a16:rowId xmlns:a16="http://schemas.microsoft.com/office/drawing/2014/main" val="10009"/>
+                  </a:ext>
+                </a:extLst>
               </a:tr>
               <a:tr h="301752">
                 <a:tc>
@@ -6224,7 +6021,7 @@
                     <a:bodyPr/>
                     <a:lstStyle/>
                     <a:p>
-                      <a:pPr indent="0" marL="0">
+                      <a:pPr marL="0" indent="0">
                         <a:buNone/>
                       </a:pPr>
                       <a:r>
@@ -6245,7 +6042,7 @@
                       </a:endParaRPr>
                     </a:p>
                   </a:txBody>
-                  <a:tcPr marL="45720" marR="45720" marT="45720" marB="45720">
+                  <a:tcPr marL="45720" marR="45720">
                     <a:lnL w="12700" cap="flat" cmpd="sng" algn="ctr">
                       <a:solidFill>
                         <a:srgbClr val="F4F7FB"/>
@@ -6292,7 +6089,7 @@
                     <a:bodyPr/>
                     <a:lstStyle/>
                     <a:p>
-                      <a:pPr indent="0" marL="0">
+                      <a:pPr marL="0" indent="0">
                         <a:buNone/>
                       </a:pPr>
                       <a:r>
@@ -6313,7 +6110,7 @@
                       </a:endParaRPr>
                     </a:p>
                   </a:txBody>
-                  <a:tcPr marL="45720" marR="45720" marT="45720" marB="45720">
+                  <a:tcPr marL="45720" marR="45720">
                     <a:lnL w="12700" cap="flat" cmpd="sng" algn="ctr">
                       <a:solidFill>
                         <a:srgbClr val="F4F7FB"/>
@@ -6360,7 +6157,7 @@
                     <a:bodyPr/>
                     <a:lstStyle/>
                     <a:p>
-                      <a:pPr indent="0" marL="0">
+                      <a:pPr marL="0" indent="0">
                         <a:buNone/>
                       </a:pPr>
                       <a:r>
@@ -6381,7 +6178,7 @@
                       </a:endParaRPr>
                     </a:p>
                   </a:txBody>
-                  <a:tcPr marL="45720" marR="45720" marT="45720" marB="45720">
+                  <a:tcPr marL="45720" marR="45720">
                     <a:lnL w="12700" cap="flat" cmpd="sng" algn="ctr">
                       <a:solidFill>
                         <a:srgbClr val="F4F7FB"/>
@@ -6423,6 +6220,11 @@
                     </a:solidFill>
                   </a:tcPr>
                 </a:tc>
+                <a:extLst>
+                  <a:ext uri="{0D108BD9-81ED-4DB2-BD59-A6C34878D82A}">
+                    <a16:rowId xmlns:a16="http://schemas.microsoft.com/office/drawing/2014/main" val="10010"/>
+                  </a:ext>
+                </a:extLst>
               </a:tr>
             </a:tbl>
           </a:graphicData>
@@ -6444,6 +6246,7 @@
         <a:solidFill>
           <a:srgbClr val="F4F7FB"/>
         </a:solidFill>
+        <a:effectLst/>
       </p:bgPr>
     </p:bg>
     <p:spTree>
@@ -6481,7 +6284,7 @@
           <a:bodyPr wrap="square" lIns="0" tIns="0" rIns="0" bIns="0" rtlCol="0" anchor="ctr"/>
           <a:lstStyle/>
           <a:p>
-            <a:pPr indent="0" marL="0">
+            <a:pPr marL="0" indent="0">
               <a:buNone/>
             </a:pPr>
             <a:r>
@@ -6520,7 +6323,7 @@
           <a:bodyPr wrap="square" lIns="0" tIns="0" rIns="0" bIns="0" rtlCol="0" anchor="ctr"/>
           <a:lstStyle/>
           <a:p>
-            <a:pPr indent="0" marL="0">
+            <a:pPr marL="0" indent="0">
               <a:buNone/>
             </a:pPr>
             <a:r>
@@ -6559,7 +6362,7 @@
           <a:bodyPr wrap="square" lIns="0" tIns="0" rIns="0" bIns="0" rtlCol="0" anchor="ctr"/>
           <a:lstStyle/>
           <a:p>
-            <a:pPr algn="r" indent="0" marL="0">
+            <a:pPr marL="0" indent="0" algn="r">
               <a:buNone/>
             </a:pPr>
             <a:r>
@@ -6603,7 +6406,7 @@
             <a:prstDash val="solid"/>
           </a:ln>
           <a:effectLst>
-            <a:outerShdw sx="100000" sy="100000" kx="0" ky="0" algn="bl" rotWithShape="0" blurRad="76200" dist="25400" dir="5400000">
+            <a:outerShdw blurRad="76200" dist="25400" dir="5400000" algn="bl" rotWithShape="0">
               <a:srgbClr val="000000">
                 <a:alpha val="8000"/>
               </a:srgbClr>
@@ -6657,7 +6460,7 @@
           <a:bodyPr wrap="square" lIns="0" tIns="0" rIns="0" bIns="0" rtlCol="0" anchor="t"/>
           <a:lstStyle/>
           <a:p>
-            <a:pPr indent="0" marL="0">
+            <a:pPr marL="0" indent="0">
               <a:buNone/>
             </a:pPr>
             <a:r>
@@ -6696,7 +6499,7 @@
           <a:bodyPr wrap="square" lIns="0" tIns="0" rIns="0" bIns="0" rtlCol="0" anchor="t"/>
           <a:lstStyle/>
           <a:p>
-            <a:pPr indent="0" marL="0">
+            <a:pPr marL="0" indent="0">
               <a:buNone/>
             </a:pPr>
             <a:r>
@@ -6740,7 +6543,7 @@
             <a:prstDash val="solid"/>
           </a:ln>
           <a:effectLst>
-            <a:outerShdw sx="100000" sy="100000" kx="0" ky="0" algn="bl" rotWithShape="0" blurRad="76200" dist="25400" dir="5400000">
+            <a:outerShdw blurRad="76200" dist="25400" dir="5400000" algn="bl" rotWithShape="0">
               <a:srgbClr val="000000">
                 <a:alpha val="8000"/>
               </a:srgbClr>
@@ -6794,7 +6597,7 @@
           <a:bodyPr wrap="square" lIns="0" tIns="0" rIns="0" bIns="0" rtlCol="0" anchor="t"/>
           <a:lstStyle/>
           <a:p>
-            <a:pPr indent="0" marL="0">
+            <a:pPr marL="0" indent="0">
               <a:buNone/>
             </a:pPr>
             <a:r>
@@ -6833,7 +6636,7 @@
           <a:bodyPr wrap="square" lIns="0" tIns="0" rIns="0" bIns="0" rtlCol="0" anchor="t"/>
           <a:lstStyle/>
           <a:p>
-            <a:pPr indent="0" marL="0">
+            <a:pPr marL="0" indent="0">
               <a:buNone/>
             </a:pPr>
             <a:r>
@@ -6877,7 +6680,7 @@
             <a:prstDash val="solid"/>
           </a:ln>
           <a:effectLst>
-            <a:outerShdw sx="100000" sy="100000" kx="0" ky="0" algn="bl" rotWithShape="0" blurRad="76200" dist="25400" dir="5400000">
+            <a:outerShdw blurRad="76200" dist="25400" dir="5400000" algn="bl" rotWithShape="0">
               <a:srgbClr val="000000">
                 <a:alpha val="8000"/>
               </a:srgbClr>
@@ -6931,7 +6734,7 @@
           <a:bodyPr wrap="square" lIns="0" tIns="0" rIns="0" bIns="0" rtlCol="0" anchor="t"/>
           <a:lstStyle/>
           <a:p>
-            <a:pPr indent="0" marL="0">
+            <a:pPr marL="0" indent="0">
               <a:buNone/>
             </a:pPr>
             <a:r>
@@ -6970,7 +6773,7 @@
           <a:bodyPr wrap="square" lIns="0" tIns="0" rIns="0" bIns="0" rtlCol="0" anchor="t"/>
           <a:lstStyle/>
           <a:p>
-            <a:pPr indent="0" marL="0">
+            <a:pPr marL="0" indent="0">
               <a:buNone/>
             </a:pPr>
             <a:r>
@@ -7014,7 +6817,7 @@
             <a:prstDash val="solid"/>
           </a:ln>
           <a:effectLst>
-            <a:outerShdw sx="100000" sy="100000" kx="0" ky="0" algn="bl" rotWithShape="0" blurRad="76200" dist="25400" dir="5400000">
+            <a:outerShdw blurRad="76200" dist="25400" dir="5400000" algn="bl" rotWithShape="0">
               <a:srgbClr val="000000">
                 <a:alpha val="8000"/>
               </a:srgbClr>
@@ -7068,7 +6871,7 @@
           <a:bodyPr wrap="square" lIns="0" tIns="0" rIns="0" bIns="0" rtlCol="0" anchor="t"/>
           <a:lstStyle/>
           <a:p>
-            <a:pPr indent="0" marL="0">
+            <a:pPr marL="0" indent="0">
               <a:buNone/>
             </a:pPr>
             <a:r>
@@ -7107,7 +6910,7 @@
           <a:bodyPr wrap="square" lIns="0" tIns="0" rIns="0" bIns="0" rtlCol="0" anchor="t"/>
           <a:lstStyle/>
           <a:p>
-            <a:pPr indent="0" marL="0">
+            <a:pPr marL="0" indent="0">
               <a:buNone/>
             </a:pPr>
             <a:r>
@@ -7151,7 +6954,7 @@
             <a:prstDash val="solid"/>
           </a:ln>
           <a:effectLst>
-            <a:outerShdw sx="100000" sy="100000" kx="0" ky="0" algn="bl" rotWithShape="0" blurRad="76200" dist="25400" dir="5400000">
+            <a:outerShdw blurRad="76200" dist="25400" dir="5400000" algn="bl" rotWithShape="0">
               <a:srgbClr val="000000">
                 <a:alpha val="8000"/>
               </a:srgbClr>
@@ -7205,7 +7008,7 @@
           <a:bodyPr wrap="square" lIns="0" tIns="0" rIns="0" bIns="0" rtlCol="0" anchor="t"/>
           <a:lstStyle/>
           <a:p>
-            <a:pPr indent="0" marL="0">
+            <a:pPr marL="0" indent="0">
               <a:buNone/>
             </a:pPr>
             <a:r>
@@ -7244,7 +7047,7 @@
           <a:bodyPr wrap="square" lIns="0" tIns="0" rIns="0" bIns="0" rtlCol="0" anchor="t"/>
           <a:lstStyle/>
           <a:p>
-            <a:pPr indent="0" marL="0">
+            <a:pPr marL="0" indent="0">
               <a:buNone/>
             </a:pPr>
             <a:r>
@@ -7278,6 +7081,7 @@
         <a:solidFill>
           <a:srgbClr val="F4F7FB"/>
         </a:solidFill>
+        <a:effectLst/>
       </p:bgPr>
     </p:bg>
     <p:spTree>
@@ -7315,7 +7119,7 @@
           <a:bodyPr wrap="square" lIns="0" tIns="0" rIns="0" bIns="0" rtlCol="0" anchor="ctr"/>
           <a:lstStyle/>
           <a:p>
-            <a:pPr indent="0" marL="0">
+            <a:pPr marL="0" indent="0">
               <a:buNone/>
             </a:pPr>
             <a:r>
@@ -7354,7 +7158,7 @@
           <a:bodyPr wrap="square" lIns="0" tIns="0" rIns="0" bIns="0" rtlCol="0" anchor="ctr"/>
           <a:lstStyle/>
           <a:p>
-            <a:pPr indent="0" marL="0">
+            <a:pPr marL="0" indent="0">
               <a:buNone/>
             </a:pPr>
             <a:r>
@@ -7393,7 +7197,7 @@
           <a:bodyPr wrap="square" lIns="0" tIns="0" rIns="0" bIns="0" rtlCol="0" anchor="ctr"/>
           <a:lstStyle/>
           <a:p>
-            <a:pPr algn="r" indent="0" marL="0">
+            <a:pPr marL="0" indent="0" algn="r">
               <a:buNone/>
             </a:pPr>
             <a:r>
@@ -7437,7 +7241,7 @@
             <a:prstDash val="solid"/>
           </a:ln>
           <a:effectLst>
-            <a:outerShdw sx="100000" sy="100000" kx="0" ky="0" algn="bl" rotWithShape="0" blurRad="76200" dist="25400" dir="5400000">
+            <a:outerShdw blurRad="76200" dist="25400" dir="5400000" algn="bl" rotWithShape="0">
               <a:srgbClr val="000000">
                 <a:alpha val="8000"/>
               </a:srgbClr>
@@ -7493,7 +7297,7 @@
           <a:bodyPr wrap="square" lIns="0" tIns="0" rIns="0" bIns="0" rtlCol="0" anchor="ctr"/>
           <a:lstStyle/>
           <a:p>
-            <a:pPr algn="ctr" indent="0" marL="0">
+            <a:pPr marL="0" indent="0" algn="ctr">
               <a:buNone/>
             </a:pPr>
             <a:r>
@@ -7532,7 +7336,7 @@
           <a:bodyPr wrap="square" lIns="0" tIns="0" rIns="0" bIns="0" rtlCol="0" anchor="ctr"/>
           <a:lstStyle/>
           <a:p>
-            <a:pPr indent="0" marL="0">
+            <a:pPr marL="0" indent="0">
               <a:buNone/>
             </a:pPr>
             <a:r>
@@ -7571,7 +7375,7 @@
           <a:bodyPr wrap="square" lIns="0" tIns="0" rIns="0" bIns="0" rtlCol="0" anchor="ctr"/>
           <a:lstStyle/>
           <a:p>
-            <a:pPr indent="0" marL="0">
+            <a:pPr marL="0" indent="0">
               <a:buNone/>
             </a:pPr>
             <a:r>
@@ -7615,7 +7419,7 @@
             <a:prstDash val="solid"/>
           </a:ln>
           <a:effectLst>
-            <a:outerShdw sx="100000" sy="100000" kx="0" ky="0" algn="bl" rotWithShape="0" blurRad="76200" dist="25400" dir="5400000">
+            <a:outerShdw blurRad="76200" dist="25400" dir="5400000" algn="bl" rotWithShape="0">
               <a:srgbClr val="000000">
                 <a:alpha val="8000"/>
               </a:srgbClr>
@@ -7671,7 +7475,7 @@
           <a:bodyPr wrap="square" lIns="0" tIns="0" rIns="0" bIns="0" rtlCol="0" anchor="ctr"/>
           <a:lstStyle/>
           <a:p>
-            <a:pPr algn="ctr" indent="0" marL="0">
+            <a:pPr marL="0" indent="0" algn="ctr">
               <a:buNone/>
             </a:pPr>
             <a:r>
@@ -7710,7 +7514,7 @@
           <a:bodyPr wrap="square" lIns="0" tIns="0" rIns="0" bIns="0" rtlCol="0" anchor="ctr"/>
           <a:lstStyle/>
           <a:p>
-            <a:pPr indent="0" marL="0">
+            <a:pPr marL="0" indent="0">
               <a:buNone/>
             </a:pPr>
             <a:r>
@@ -7749,7 +7553,7 @@
           <a:bodyPr wrap="square" lIns="0" tIns="0" rIns="0" bIns="0" rtlCol="0" anchor="ctr"/>
           <a:lstStyle/>
           <a:p>
-            <a:pPr indent="0" marL="0">
+            <a:pPr marL="0" indent="0">
               <a:buNone/>
             </a:pPr>
             <a:r>
@@ -7793,7 +7597,7 @@
             <a:prstDash val="solid"/>
           </a:ln>
           <a:effectLst>
-            <a:outerShdw sx="100000" sy="100000" kx="0" ky="0" algn="bl" rotWithShape="0" blurRad="76200" dist="25400" dir="5400000">
+            <a:outerShdw blurRad="76200" dist="25400" dir="5400000" algn="bl" rotWithShape="0">
               <a:srgbClr val="000000">
                 <a:alpha val="8000"/>
               </a:srgbClr>
@@ -7849,7 +7653,7 @@
           <a:bodyPr wrap="square" lIns="0" tIns="0" rIns="0" bIns="0" rtlCol="0" anchor="ctr"/>
           <a:lstStyle/>
           <a:p>
-            <a:pPr algn="ctr" indent="0" marL="0">
+            <a:pPr marL="0" indent="0" algn="ctr">
               <a:buNone/>
             </a:pPr>
             <a:r>
@@ -7888,7 +7692,7 @@
           <a:bodyPr wrap="square" lIns="0" tIns="0" rIns="0" bIns="0" rtlCol="0" anchor="ctr"/>
           <a:lstStyle/>
           <a:p>
-            <a:pPr indent="0" marL="0">
+            <a:pPr marL="0" indent="0">
               <a:buNone/>
             </a:pPr>
             <a:r>
@@ -7927,7 +7731,7 @@
           <a:bodyPr wrap="square" lIns="0" tIns="0" rIns="0" bIns="0" rtlCol="0" anchor="ctr"/>
           <a:lstStyle/>
           <a:p>
-            <a:pPr indent="0" marL="0">
+            <a:pPr marL="0" indent="0">
               <a:buNone/>
             </a:pPr>
             <a:r>
@@ -7971,7 +7775,7 @@
             <a:prstDash val="solid"/>
           </a:ln>
           <a:effectLst>
-            <a:outerShdw sx="100000" sy="100000" kx="0" ky="0" algn="bl" rotWithShape="0" blurRad="76200" dist="25400" dir="5400000">
+            <a:outerShdw blurRad="76200" dist="25400" dir="5400000" algn="bl" rotWithShape="0">
               <a:srgbClr val="000000">
                 <a:alpha val="8000"/>
               </a:srgbClr>
@@ -8027,7 +7831,7 @@
           <a:bodyPr wrap="square" lIns="0" tIns="0" rIns="0" bIns="0" rtlCol="0" anchor="ctr"/>
           <a:lstStyle/>
           <a:p>
-            <a:pPr algn="ctr" indent="0" marL="0">
+            <a:pPr marL="0" indent="0" algn="ctr">
               <a:buNone/>
             </a:pPr>
             <a:r>
@@ -8066,7 +7870,7 @@
           <a:bodyPr wrap="square" lIns="0" tIns="0" rIns="0" bIns="0" rtlCol="0" anchor="ctr"/>
           <a:lstStyle/>
           <a:p>
-            <a:pPr indent="0" marL="0">
+            <a:pPr marL="0" indent="0">
               <a:buNone/>
             </a:pPr>
             <a:r>
@@ -8105,7 +7909,7 @@
           <a:bodyPr wrap="square" lIns="0" tIns="0" rIns="0" bIns="0" rtlCol="0" anchor="ctr"/>
           <a:lstStyle/>
           <a:p>
-            <a:pPr indent="0" marL="0">
+            <a:pPr marL="0" indent="0">
               <a:buNone/>
             </a:pPr>
             <a:r>
@@ -8149,7 +7953,7 @@
             <a:prstDash val="solid"/>
           </a:ln>
           <a:effectLst>
-            <a:outerShdw sx="100000" sy="100000" kx="0" ky="0" algn="bl" rotWithShape="0" blurRad="76200" dist="25400" dir="5400000">
+            <a:outerShdw blurRad="76200" dist="25400" dir="5400000" algn="bl" rotWithShape="0">
               <a:srgbClr val="000000">
                 <a:alpha val="8000"/>
               </a:srgbClr>
@@ -8205,7 +8009,7 @@
           <a:bodyPr wrap="square" lIns="0" tIns="0" rIns="0" bIns="0" rtlCol="0" anchor="ctr"/>
           <a:lstStyle/>
           <a:p>
-            <a:pPr algn="ctr" indent="0" marL="0">
+            <a:pPr marL="0" indent="0" algn="ctr">
               <a:buNone/>
             </a:pPr>
             <a:r>
@@ -8244,7 +8048,7 @@
           <a:bodyPr wrap="square" lIns="0" tIns="0" rIns="0" bIns="0" rtlCol="0" anchor="ctr"/>
           <a:lstStyle/>
           <a:p>
-            <a:pPr indent="0" marL="0">
+            <a:pPr marL="0" indent="0">
               <a:buNone/>
             </a:pPr>
             <a:r>
@@ -8283,7 +8087,7 @@
           <a:bodyPr wrap="square" lIns="0" tIns="0" rIns="0" bIns="0" rtlCol="0" anchor="ctr"/>
           <a:lstStyle/>
           <a:p>
-            <a:pPr indent="0" marL="0">
+            <a:pPr marL="0" indent="0">
               <a:buNone/>
             </a:pPr>
             <a:r>
@@ -8322,7 +8126,7 @@
           <a:bodyPr wrap="square" lIns="0" tIns="0" rIns="0" bIns="0" rtlCol="0" anchor="t"/>
           <a:lstStyle/>
           <a:p>
-            <a:pPr indent="0" marL="0">
+            <a:pPr marL="0" indent="0">
               <a:buNone/>
             </a:pPr>
             <a:r>
@@ -8356,6 +8160,7 @@
         <a:solidFill>
           <a:srgbClr val="F4F7FB"/>
         </a:solidFill>
+        <a:effectLst/>
       </p:bgPr>
     </p:bg>
     <p:spTree>
@@ -8393,7 +8198,7 @@
           <a:bodyPr wrap="square" lIns="0" tIns="0" rIns="0" bIns="0" rtlCol="0" anchor="ctr"/>
           <a:lstStyle/>
           <a:p>
-            <a:pPr indent="0" marL="0">
+            <a:pPr marL="0" indent="0">
               <a:buNone/>
             </a:pPr>
             <a:r>
@@ -8432,7 +8237,7 @@
           <a:bodyPr wrap="square" lIns="0" tIns="0" rIns="0" bIns="0" rtlCol="0" anchor="ctr"/>
           <a:lstStyle/>
           <a:p>
-            <a:pPr indent="0" marL="0">
+            <a:pPr marL="0" indent="0">
               <a:buNone/>
             </a:pPr>
             <a:r>
@@ -8471,7 +8276,7 @@
           <a:bodyPr wrap="square" lIns="0" tIns="0" rIns="0" bIns="0" rtlCol="0" anchor="ctr"/>
           <a:lstStyle/>
           <a:p>
-            <a:pPr algn="r" indent="0" marL="0">
+            <a:pPr marL="0" indent="0" algn="r">
               <a:buNone/>
             </a:pPr>
             <a:r>
@@ -8515,7 +8320,7 @@
             <a:prstDash val="solid"/>
           </a:ln>
           <a:effectLst>
-            <a:outerShdw sx="100000" sy="100000" kx="0" ky="0" algn="bl" rotWithShape="0" blurRad="76200" dist="25400" dir="5400000">
+            <a:outerShdw blurRad="76200" dist="25400" dir="5400000" algn="bl" rotWithShape="0">
               <a:srgbClr val="000000">
                 <a:alpha val="8000"/>
               </a:srgbClr>
@@ -8544,7 +8349,7 @@
           <a:bodyPr wrap="square" lIns="0" tIns="0" rIns="0" bIns="0" rtlCol="0" anchor="t"/>
           <a:lstStyle/>
           <a:p>
-            <a:pPr indent="0" marL="0">
+            <a:pPr marL="0" indent="0">
               <a:buNone/>
             </a:pPr>
             <a:r>
@@ -8694,7 +8499,7 @@
             <a:prstDash val="solid"/>
           </a:ln>
           <a:effectLst>
-            <a:outerShdw sx="100000" sy="100000" kx="0" ky="0" algn="bl" rotWithShape="0" blurRad="76200" dist="25400" dir="5400000">
+            <a:outerShdw blurRad="76200" dist="25400" dir="5400000" algn="bl" rotWithShape="0">
               <a:srgbClr val="000000">
                 <a:alpha val="8000"/>
               </a:srgbClr>
@@ -8723,7 +8528,7 @@
           <a:bodyPr wrap="square" lIns="0" tIns="0" rIns="0" bIns="0" rtlCol="0" anchor="t"/>
           <a:lstStyle/>
           <a:p>
-            <a:pPr indent="0" marL="0">
+            <a:pPr marL="0" indent="0">
               <a:buNone/>
             </a:pPr>
             <a:r>
@@ -8863,6 +8668,7 @@
         <a:solidFill>
           <a:srgbClr val="1B2430"/>
         </a:solidFill>
+        <a:effectLst/>
       </p:bgPr>
     </p:bg>
     <p:spTree>
@@ -8900,7 +8706,7 @@
           <a:bodyPr wrap="square" lIns="0" tIns="0" rIns="0" bIns="0" rtlCol="0" anchor="ctr"/>
           <a:lstStyle/>
           <a:p>
-            <a:pPr indent="0" marL="0">
+            <a:pPr marL="0" indent="0">
               <a:buNone/>
             </a:pPr>
             <a:r>
@@ -8966,7 +8772,7 @@
           <a:bodyPr wrap="square" lIns="0" tIns="0" rIns="0" bIns="0" rtlCol="0" anchor="ctr"/>
           <a:lstStyle/>
           <a:p>
-            <a:pPr indent="0" marL="0">
+            <a:pPr marL="0" indent="0">
               <a:buNone/>
             </a:pPr>
             <a:r>
@@ -9005,7 +8811,7 @@
           <a:bodyPr wrap="square" lIns="0" tIns="0" rIns="0" bIns="0" rtlCol="0" anchor="ctr"/>
           <a:lstStyle/>
           <a:p>
-            <a:pPr indent="0" marL="0">
+            <a:pPr marL="0" indent="0">
               <a:buNone/>
             </a:pPr>
             <a:r>
@@ -9071,7 +8877,7 @@
           <a:bodyPr wrap="square" lIns="0" tIns="0" rIns="0" bIns="0" rtlCol="0" anchor="ctr"/>
           <a:lstStyle/>
           <a:p>
-            <a:pPr indent="0" marL="0">
+            <a:pPr marL="0" indent="0">
               <a:buNone/>
             </a:pPr>
             <a:r>
@@ -9110,7 +8916,7 @@
           <a:bodyPr wrap="square" lIns="0" tIns="0" rIns="0" bIns="0" rtlCol="0" anchor="ctr"/>
           <a:lstStyle/>
           <a:p>
-            <a:pPr indent="0" marL="0">
+            <a:pPr marL="0" indent="0">
               <a:buNone/>
             </a:pPr>
             <a:r>
@@ -9176,7 +8982,7 @@
           <a:bodyPr wrap="square" lIns="0" tIns="0" rIns="0" bIns="0" rtlCol="0" anchor="ctr"/>
           <a:lstStyle/>
           <a:p>
-            <a:pPr indent="0" marL="0">
+            <a:pPr marL="0" indent="0">
               <a:buNone/>
             </a:pPr>
             <a:r>
@@ -9215,7 +9021,7 @@
           <a:bodyPr wrap="square" lIns="0" tIns="0" rIns="0" bIns="0" rtlCol="0" anchor="ctr"/>
           <a:lstStyle/>
           <a:p>
-            <a:pPr indent="0" marL="0">
+            <a:pPr marL="0" indent="0">
               <a:buNone/>
             </a:pPr>
             <a:r>
@@ -9281,7 +9087,7 @@
           <a:bodyPr wrap="square" lIns="0" tIns="0" rIns="0" bIns="0" rtlCol="0" anchor="ctr"/>
           <a:lstStyle/>
           <a:p>
-            <a:pPr indent="0" marL="0">
+            <a:pPr marL="0" indent="0">
               <a:buNone/>
             </a:pPr>
             <a:r>
@@ -9320,7 +9126,7 @@
           <a:bodyPr wrap="square" lIns="0" tIns="0" rIns="0" bIns="0" rtlCol="0" anchor="ctr"/>
           <a:lstStyle/>
           <a:p>
-            <a:pPr indent="0" marL="0">
+            <a:pPr marL="0" indent="0">
               <a:buNone/>
             </a:pPr>
             <a:r>
@@ -9386,7 +9192,7 @@
           <a:bodyPr wrap="square" lIns="0" tIns="0" rIns="0" bIns="0" rtlCol="0" anchor="ctr"/>
           <a:lstStyle/>
           <a:p>
-            <a:pPr indent="0" marL="0">
+            <a:pPr marL="0" indent="0">
               <a:buNone/>
             </a:pPr>
             <a:r>
@@ -9425,7 +9231,7 @@
           <a:bodyPr wrap="square" lIns="0" tIns="0" rIns="0" bIns="0" rtlCol="0" anchor="ctr"/>
           <a:lstStyle/>
           <a:p>
-            <a:pPr indent="0" marL="0">
+            <a:pPr marL="0" indent="0">
               <a:buNone/>
             </a:pPr>
             <a:r>
@@ -9491,7 +9297,7 @@
           <a:bodyPr wrap="square" lIns="0" tIns="0" rIns="0" bIns="0" rtlCol="0" anchor="ctr"/>
           <a:lstStyle/>
           <a:p>
-            <a:pPr indent="0" marL="0">
+            <a:pPr marL="0" indent="0">
               <a:buNone/>
             </a:pPr>
             <a:r>
@@ -9530,7 +9336,7 @@
           <a:bodyPr wrap="square" lIns="0" tIns="0" rIns="0" bIns="0" rtlCol="0" anchor="ctr"/>
           <a:lstStyle/>
           <a:p>
-            <a:pPr indent="0" marL="0">
+            <a:pPr marL="0" indent="0">
               <a:buNone/>
             </a:pPr>
             <a:r>
@@ -9569,7 +9375,7 @@
           <a:bodyPr wrap="square" lIns="0" tIns="0" rIns="0" bIns="0" rtlCol="0" anchor="ctr"/>
           <a:lstStyle/>
           <a:p>
-            <a:pPr indent="0" marL="0">
+            <a:pPr marL="0" indent="0">
               <a:buNone/>
             </a:pPr>
             <a:r>
@@ -9608,7 +9414,7 @@
           <a:bodyPr wrap="square" lIns="0" tIns="0" rIns="0" bIns="0" rtlCol="0" anchor="ctr"/>
           <a:lstStyle/>
           <a:p>
-            <a:pPr indent="0" marL="0">
+            <a:pPr marL="0" indent="0">
               <a:buNone/>
             </a:pPr>
             <a:r>
@@ -9642,6 +9448,7 @@
         <a:solidFill>
           <a:srgbClr val="F4F7FB"/>
         </a:solidFill>
+        <a:effectLst/>
       </p:bgPr>
     </p:bg>
     <p:spTree>
@@ -9679,7 +9486,7 @@
           <a:bodyPr wrap="square" lIns="0" tIns="0" rIns="0" bIns="0" rtlCol="0" anchor="ctr"/>
           <a:lstStyle/>
           <a:p>
-            <a:pPr indent="0" marL="0">
+            <a:pPr marL="0" indent="0">
               <a:buNone/>
             </a:pPr>
             <a:r>
@@ -9718,7 +9525,7 @@
           <a:bodyPr wrap="square" lIns="0" tIns="0" rIns="0" bIns="0" rtlCol="0" anchor="ctr"/>
           <a:lstStyle/>
           <a:p>
-            <a:pPr indent="0" marL="0">
+            <a:pPr marL="0" indent="0">
               <a:buNone/>
             </a:pPr>
             <a:r>
@@ -9757,7 +9564,7 @@
           <a:bodyPr wrap="square" lIns="0" tIns="0" rIns="0" bIns="0" rtlCol="0" anchor="ctr"/>
           <a:lstStyle/>
           <a:p>
-            <a:pPr algn="r" indent="0" marL="0">
+            <a:pPr marL="0" indent="0" algn="r">
               <a:buNone/>
             </a:pPr>
             <a:r>
@@ -9801,7 +9608,7 @@
             <a:prstDash val="solid"/>
           </a:ln>
           <a:effectLst>
-            <a:outerShdw sx="100000" sy="100000" kx="0" ky="0" algn="bl" rotWithShape="0" blurRad="76200" dist="25400" dir="5400000">
+            <a:outerShdw blurRad="76200" dist="25400" dir="5400000" algn="bl" rotWithShape="0">
               <a:srgbClr val="000000">
                 <a:alpha val="8000"/>
               </a:srgbClr>
@@ -9855,7 +9662,7 @@
           <a:bodyPr wrap="square" lIns="0" tIns="0" rIns="0" bIns="0" rtlCol="0" anchor="ctr"/>
           <a:lstStyle/>
           <a:p>
-            <a:pPr algn="ctr" indent="0" marL="0">
+            <a:pPr marL="0" indent="0" algn="ctr">
               <a:buNone/>
             </a:pPr>
             <a:r>
@@ -9894,7 +9701,7 @@
           <a:bodyPr wrap="square" lIns="0" tIns="0" rIns="0" bIns="0" rtlCol="0" anchor="t"/>
           <a:lstStyle/>
           <a:p>
-            <a:pPr indent="0" marL="0">
+            <a:pPr marL="0" indent="0">
               <a:buNone/>
             </a:pPr>
             <a:r>
@@ -9933,7 +9740,7 @@
           <a:bodyPr wrap="square" lIns="0" tIns="0" rIns="0" bIns="0" rtlCol="0" anchor="t"/>
           <a:lstStyle/>
           <a:p>
-            <a:pPr indent="0" marL="0">
+            <a:pPr marL="0" indent="0">
               <a:buNone/>
             </a:pPr>
             <a:r>
@@ -9977,7 +9784,7 @@
             <a:prstDash val="solid"/>
           </a:ln>
           <a:effectLst>
-            <a:outerShdw sx="100000" sy="100000" kx="0" ky="0" algn="bl" rotWithShape="0" blurRad="76200" dist="25400" dir="5400000">
+            <a:outerShdw blurRad="76200" dist="25400" dir="5400000" algn="bl" rotWithShape="0">
               <a:srgbClr val="000000">
                 <a:alpha val="8000"/>
               </a:srgbClr>
@@ -10031,7 +9838,7 @@
           <a:bodyPr wrap="square" lIns="0" tIns="0" rIns="0" bIns="0" rtlCol="0" anchor="ctr"/>
           <a:lstStyle/>
           <a:p>
-            <a:pPr algn="ctr" indent="0" marL="0">
+            <a:pPr marL="0" indent="0" algn="ctr">
               <a:buNone/>
             </a:pPr>
             <a:r>
@@ -10070,7 +9877,7 @@
           <a:bodyPr wrap="square" lIns="0" tIns="0" rIns="0" bIns="0" rtlCol="0" anchor="t"/>
           <a:lstStyle/>
           <a:p>
-            <a:pPr indent="0" marL="0">
+            <a:pPr marL="0" indent="0">
               <a:buNone/>
             </a:pPr>
             <a:r>
@@ -10109,7 +9916,7 @@
           <a:bodyPr wrap="square" lIns="0" tIns="0" rIns="0" bIns="0" rtlCol="0" anchor="t"/>
           <a:lstStyle/>
           <a:p>
-            <a:pPr indent="0" marL="0">
+            <a:pPr marL="0" indent="0">
               <a:buNone/>
             </a:pPr>
             <a:r>
@@ -10153,7 +9960,7 @@
             <a:prstDash val="solid"/>
           </a:ln>
           <a:effectLst>
-            <a:outerShdw sx="100000" sy="100000" kx="0" ky="0" algn="bl" rotWithShape="0" blurRad="76200" dist="25400" dir="5400000">
+            <a:outerShdw blurRad="76200" dist="25400" dir="5400000" algn="bl" rotWithShape="0">
               <a:srgbClr val="000000">
                 <a:alpha val="8000"/>
               </a:srgbClr>
@@ -10207,7 +10014,7 @@
           <a:bodyPr wrap="square" lIns="0" tIns="0" rIns="0" bIns="0" rtlCol="0" anchor="ctr"/>
           <a:lstStyle/>
           <a:p>
-            <a:pPr algn="ctr" indent="0" marL="0">
+            <a:pPr marL="0" indent="0" algn="ctr">
               <a:buNone/>
             </a:pPr>
             <a:r>
@@ -10246,7 +10053,7 @@
           <a:bodyPr wrap="square" lIns="0" tIns="0" rIns="0" bIns="0" rtlCol="0" anchor="t"/>
           <a:lstStyle/>
           <a:p>
-            <a:pPr indent="0" marL="0">
+            <a:pPr marL="0" indent="0">
               <a:buNone/>
             </a:pPr>
             <a:r>
@@ -10285,7 +10092,7 @@
           <a:bodyPr wrap="square" lIns="0" tIns="0" rIns="0" bIns="0" rtlCol="0" anchor="t"/>
           <a:lstStyle/>
           <a:p>
-            <a:pPr indent="0" marL="0">
+            <a:pPr marL="0" indent="0">
               <a:buNone/>
             </a:pPr>
             <a:r>
@@ -10329,7 +10136,7 @@
             <a:prstDash val="solid"/>
           </a:ln>
           <a:effectLst>
-            <a:outerShdw sx="100000" sy="100000" kx="0" ky="0" algn="bl" rotWithShape="0" blurRad="76200" dist="25400" dir="5400000">
+            <a:outerShdw blurRad="76200" dist="25400" dir="5400000" algn="bl" rotWithShape="0">
               <a:srgbClr val="000000">
                 <a:alpha val="8000"/>
               </a:srgbClr>
@@ -10358,7 +10165,7 @@
           <a:bodyPr wrap="square" lIns="0" tIns="0" rIns="0" bIns="0" rtlCol="0" anchor="ctr"/>
           <a:lstStyle/>
           <a:p>
-            <a:pPr indent="0" marL="0">
+            <a:pPr marL="0" indent="0">
               <a:buNone/>
             </a:pPr>
             <a:r>
@@ -10397,7 +10204,7 @@
           <a:bodyPr wrap="square" lIns="0" tIns="0" rIns="0" bIns="0" rtlCol="0" anchor="ctr"/>
           <a:lstStyle/>
           <a:p>
-            <a:pPr indent="0" marL="0">
+            <a:pPr marL="0" indent="0">
               <a:buNone/>
             </a:pPr>
             <a:r>
@@ -10431,6 +10238,7 @@
         <a:solidFill>
           <a:srgbClr val="F4F7FB"/>
         </a:solidFill>
+        <a:effectLst/>
       </p:bgPr>
     </p:bg>
     <p:spTree>
@@ -10468,7 +10276,7 @@
           <a:bodyPr wrap="square" lIns="0" tIns="0" rIns="0" bIns="0" rtlCol="0" anchor="ctr"/>
           <a:lstStyle/>
           <a:p>
-            <a:pPr indent="0" marL="0">
+            <a:pPr marL="0" indent="0">
               <a:buNone/>
             </a:pPr>
             <a:r>
@@ -10507,7 +10315,7 @@
           <a:bodyPr wrap="square" lIns="0" tIns="0" rIns="0" bIns="0" rtlCol="0" anchor="ctr"/>
           <a:lstStyle/>
           <a:p>
-            <a:pPr indent="0" marL="0">
+            <a:pPr marL="0" indent="0">
               <a:buNone/>
             </a:pPr>
             <a:r>
@@ -10546,7 +10354,7 @@
           <a:bodyPr wrap="square" lIns="0" tIns="0" rIns="0" bIns="0" rtlCol="0" anchor="ctr"/>
           <a:lstStyle/>
           <a:p>
-            <a:pPr algn="r" indent="0" marL="0">
+            <a:pPr marL="0" indent="0" algn="r">
               <a:buNone/>
             </a:pPr>
             <a:r>
@@ -10590,7 +10398,7 @@
             <a:prstDash val="solid"/>
           </a:ln>
           <a:effectLst>
-            <a:outerShdw sx="100000" sy="100000" kx="0" ky="0" algn="bl" rotWithShape="0" blurRad="76200" dist="25400" dir="5400000">
+            <a:outerShdw blurRad="76200" dist="25400" dir="5400000" algn="bl" rotWithShape="0">
               <a:srgbClr val="000000">
                 <a:alpha val="8000"/>
               </a:srgbClr>
@@ -10644,7 +10452,7 @@
           <a:bodyPr wrap="square" lIns="0" tIns="0" rIns="0" bIns="0" rtlCol="0" anchor="ctr"/>
           <a:lstStyle/>
           <a:p>
-            <a:pPr algn="ctr" indent="0" marL="0">
+            <a:pPr marL="0" indent="0" algn="ctr">
               <a:buNone/>
             </a:pPr>
             <a:r>
@@ -10683,7 +10491,7 @@
           <a:bodyPr wrap="square" lIns="0" tIns="0" rIns="0" bIns="0" rtlCol="0" anchor="t"/>
           <a:lstStyle/>
           <a:p>
-            <a:pPr indent="0" marL="0">
+            <a:pPr marL="0" indent="0">
               <a:buNone/>
             </a:pPr>
             <a:r>
@@ -10722,7 +10530,7 @@
           <a:bodyPr wrap="square" lIns="0" tIns="0" rIns="0" bIns="0" rtlCol="0" anchor="t"/>
           <a:lstStyle/>
           <a:p>
-            <a:pPr indent="0" marL="0">
+            <a:pPr marL="0" indent="0">
               <a:buNone/>
             </a:pPr>
             <a:r>
@@ -10766,7 +10574,7 @@
             <a:prstDash val="solid"/>
           </a:ln>
           <a:effectLst>
-            <a:outerShdw sx="100000" sy="100000" kx="0" ky="0" algn="bl" rotWithShape="0" blurRad="76200" dist="25400" dir="5400000">
+            <a:outerShdw blurRad="76200" dist="25400" dir="5400000" algn="bl" rotWithShape="0">
               <a:srgbClr val="000000">
                 <a:alpha val="8000"/>
               </a:srgbClr>
@@ -10820,7 +10628,7 @@
           <a:bodyPr wrap="square" lIns="0" tIns="0" rIns="0" bIns="0" rtlCol="0" anchor="ctr"/>
           <a:lstStyle/>
           <a:p>
-            <a:pPr algn="ctr" indent="0" marL="0">
+            <a:pPr marL="0" indent="0" algn="ctr">
               <a:buNone/>
             </a:pPr>
             <a:r>
@@ -10859,7 +10667,7 @@
           <a:bodyPr wrap="square" lIns="0" tIns="0" rIns="0" bIns="0" rtlCol="0" anchor="t"/>
           <a:lstStyle/>
           <a:p>
-            <a:pPr indent="0" marL="0">
+            <a:pPr marL="0" indent="0">
               <a:buNone/>
             </a:pPr>
             <a:r>
@@ -10898,7 +10706,7 @@
           <a:bodyPr wrap="square" lIns="0" tIns="0" rIns="0" bIns="0" rtlCol="0" anchor="t"/>
           <a:lstStyle/>
           <a:p>
-            <a:pPr indent="0" marL="0">
+            <a:pPr marL="0" indent="0">
               <a:buNone/>
             </a:pPr>
             <a:r>
@@ -10942,7 +10750,7 @@
             <a:prstDash val="solid"/>
           </a:ln>
           <a:effectLst>
-            <a:outerShdw sx="100000" sy="100000" kx="0" ky="0" algn="bl" rotWithShape="0" blurRad="76200" dist="25400" dir="5400000">
+            <a:outerShdw blurRad="76200" dist="25400" dir="5400000" algn="bl" rotWithShape="0">
               <a:srgbClr val="000000">
                 <a:alpha val="8000"/>
               </a:srgbClr>
@@ -10996,7 +10804,7 @@
           <a:bodyPr wrap="square" lIns="0" tIns="0" rIns="0" bIns="0" rtlCol="0" anchor="ctr"/>
           <a:lstStyle/>
           <a:p>
-            <a:pPr algn="ctr" indent="0" marL="0">
+            <a:pPr marL="0" indent="0" algn="ctr">
               <a:buNone/>
             </a:pPr>
             <a:r>
@@ -11035,7 +10843,7 @@
           <a:bodyPr wrap="square" lIns="0" tIns="0" rIns="0" bIns="0" rtlCol="0" anchor="t"/>
           <a:lstStyle/>
           <a:p>
-            <a:pPr indent="0" marL="0">
+            <a:pPr marL="0" indent="0">
               <a:buNone/>
             </a:pPr>
             <a:r>
@@ -11074,7 +10882,7 @@
           <a:bodyPr wrap="square" lIns="0" tIns="0" rIns="0" bIns="0" rtlCol="0" anchor="t"/>
           <a:lstStyle/>
           <a:p>
-            <a:pPr indent="0" marL="0">
+            <a:pPr marL="0" indent="0">
               <a:buNone/>
             </a:pPr>
             <a:r>
@@ -11118,7 +10926,7 @@
             <a:prstDash val="solid"/>
           </a:ln>
           <a:effectLst>
-            <a:outerShdw sx="100000" sy="100000" kx="0" ky="0" algn="bl" rotWithShape="0" blurRad="76200" dist="25400" dir="5400000">
+            <a:outerShdw blurRad="76200" dist="25400" dir="5400000" algn="bl" rotWithShape="0">
               <a:srgbClr val="000000">
                 <a:alpha val="8000"/>
               </a:srgbClr>
@@ -11172,7 +10980,7 @@
           <a:bodyPr wrap="square" lIns="0" tIns="0" rIns="0" bIns="0" rtlCol="0" anchor="ctr"/>
           <a:lstStyle/>
           <a:p>
-            <a:pPr algn="ctr" indent="0" marL="0">
+            <a:pPr marL="0" indent="0" algn="ctr">
               <a:buNone/>
             </a:pPr>
             <a:r>
@@ -11211,7 +11019,7 @@
           <a:bodyPr wrap="square" lIns="0" tIns="0" rIns="0" bIns="0" rtlCol="0" anchor="t"/>
           <a:lstStyle/>
           <a:p>
-            <a:pPr indent="0" marL="0">
+            <a:pPr marL="0" indent="0">
               <a:buNone/>
             </a:pPr>
             <a:r>
@@ -11250,7 +11058,7 @@
           <a:bodyPr wrap="square" lIns="0" tIns="0" rIns="0" bIns="0" rtlCol="0" anchor="t"/>
           <a:lstStyle/>
           <a:p>
-            <a:pPr indent="0" marL="0">
+            <a:pPr marL="0" indent="0">
               <a:buNone/>
             </a:pPr>
             <a:r>
@@ -11289,7 +11097,7 @@
           <a:bodyPr wrap="square" lIns="0" tIns="0" rIns="0" bIns="0" rtlCol="0" anchor="t"/>
           <a:lstStyle/>
           <a:p>
-            <a:pPr indent="0" marL="0">
+            <a:pPr marL="0" indent="0">
               <a:buNone/>
             </a:pPr>
             <a:r>
@@ -11323,6 +11131,7 @@
         <a:solidFill>
           <a:srgbClr val="F4F7FB"/>
         </a:solidFill>
+        <a:effectLst/>
       </p:bgPr>
     </p:bg>
     <p:spTree>
@@ -11360,7 +11169,7 @@
           <a:bodyPr wrap="square" lIns="0" tIns="0" rIns="0" bIns="0" rtlCol="0" anchor="ctr"/>
           <a:lstStyle/>
           <a:p>
-            <a:pPr indent="0" marL="0">
+            <a:pPr marL="0" indent="0">
               <a:buNone/>
             </a:pPr>
             <a:r>
@@ -11399,7 +11208,7 @@
           <a:bodyPr wrap="square" lIns="0" tIns="0" rIns="0" bIns="0" rtlCol="0" anchor="ctr"/>
           <a:lstStyle/>
           <a:p>
-            <a:pPr indent="0" marL="0">
+            <a:pPr marL="0" indent="0">
               <a:buNone/>
             </a:pPr>
             <a:r>
@@ -11438,7 +11247,7 @@
           <a:bodyPr wrap="square" lIns="0" tIns="0" rIns="0" bIns="0" rtlCol="0" anchor="ctr"/>
           <a:lstStyle/>
           <a:p>
-            <a:pPr algn="r" indent="0" marL="0">
+            <a:pPr marL="0" indent="0" algn="r">
               <a:buNone/>
             </a:pPr>
             <a:r>
@@ -11504,7 +11313,7 @@
           <a:bodyPr wrap="square" lIns="0" tIns="0" rIns="0" bIns="0" rtlCol="0" anchor="ctr"/>
           <a:lstStyle/>
           <a:p>
-            <a:pPr algn="ctr" indent="0" marL="0">
+            <a:pPr marL="0" indent="0" algn="ctr">
               <a:buNone/>
             </a:pPr>
             <a:r>
@@ -11521,7 +11330,7 @@
             <a:endParaRPr lang="en-US" sz="1300" dirty="0"/>
           </a:p>
           <a:p>
-            <a:pPr algn="ctr" indent="0" marL="0">
+            <a:pPr marL="0" indent="0" algn="ctr">
               <a:buNone/>
             </a:pPr>
             <a:r>
@@ -11587,7 +11396,7 @@
           <a:bodyPr wrap="square" lIns="0" tIns="0" rIns="0" bIns="0" rtlCol="0" anchor="ctr"/>
           <a:lstStyle/>
           <a:p>
-            <a:pPr algn="ctr" indent="0" marL="0">
+            <a:pPr marL="0" indent="0" algn="ctr">
               <a:buNone/>
             </a:pPr>
             <a:r>
@@ -11604,7 +11413,7 @@
             <a:endParaRPr lang="en-US" sz="1200" dirty="0"/>
           </a:p>
           <a:p>
-            <a:pPr algn="ctr" indent="0" marL="0">
+            <a:pPr marL="0" indent="0" algn="ctr">
               <a:buNone/>
             </a:pPr>
             <a:r>
@@ -11670,7 +11479,7 @@
           <a:bodyPr wrap="square" lIns="0" tIns="0" rIns="0" bIns="0" rtlCol="0" anchor="ctr"/>
           <a:lstStyle/>
           <a:p>
-            <a:pPr algn="ctr" indent="0" marL="0">
+            <a:pPr marL="0" indent="0" algn="ctr">
               <a:buNone/>
             </a:pPr>
             <a:r>
@@ -11687,7 +11496,7 @@
             <a:endParaRPr lang="en-US" sz="1200" dirty="0"/>
           </a:p>
           <a:p>
-            <a:pPr algn="ctr" indent="0" marL="0">
+            <a:pPr marL="0" indent="0" algn="ctr">
               <a:buNone/>
             </a:pPr>
             <a:r>
@@ -11750,7 +11559,7 @@
           <a:bodyPr wrap="square" lIns="0" tIns="0" rIns="0" bIns="0" rtlCol="0" anchor="t"/>
           <a:lstStyle/>
           <a:p>
-            <a:pPr algn="ctr" indent="0" marL="0">
+            <a:pPr marL="0" indent="0" algn="ctr">
               <a:buNone/>
             </a:pPr>
             <a:r>
@@ -11883,7 +11692,7 @@
           <a:bodyPr wrap="square" lIns="0" tIns="0" rIns="0" bIns="0" rtlCol="0" anchor="t"/>
           <a:lstStyle/>
           <a:p>
-            <a:pPr algn="ctr" indent="0" marL="0">
+            <a:pPr marL="0" indent="0" algn="ctr">
               <a:buNone/>
             </a:pPr>
             <a:r>
@@ -11949,7 +11758,7 @@
           <a:bodyPr wrap="square" lIns="0" tIns="0" rIns="0" bIns="0" rtlCol="0" anchor="ctr"/>
           <a:lstStyle/>
           <a:p>
-            <a:pPr algn="ctr" indent="0" marL="0">
+            <a:pPr marL="0" indent="0" algn="ctr">
               <a:buNone/>
             </a:pPr>
             <a:r>
@@ -12015,7 +11824,7 @@
           <a:bodyPr wrap="square" lIns="0" tIns="0" rIns="0" bIns="0" rtlCol="0" anchor="ctr"/>
           <a:lstStyle/>
           <a:p>
-            <a:pPr algn="ctr" indent="0" marL="0">
+            <a:pPr marL="0" indent="0" algn="ctr">
               <a:buNone/>
             </a:pPr>
             <a:r>
@@ -12129,7 +11938,7 @@
           <a:bodyPr wrap="square" lIns="0" tIns="0" rIns="0" bIns="0" rtlCol="0" anchor="ctr"/>
           <a:lstStyle/>
           <a:p>
-            <a:pPr algn="ctr" indent="0" marL="0">
+            <a:pPr marL="0" indent="0" algn="ctr">
               <a:buNone/>
             </a:pPr>
             <a:r>
@@ -12146,7 +11955,7 @@
             <a:endParaRPr lang="en-US" sz="1000" dirty="0"/>
           </a:p>
           <a:p>
-            <a:pPr algn="ctr" indent="0" marL="0">
+            <a:pPr marL="0" indent="0" algn="ctr">
               <a:buNone/>
             </a:pPr>
             <a:r>
@@ -12212,7 +12021,7 @@
           <a:bodyPr wrap="square" lIns="0" tIns="0" rIns="0" bIns="0" rtlCol="0" anchor="ctr"/>
           <a:lstStyle/>
           <a:p>
-            <a:pPr algn="ctr" indent="0" marL="0">
+            <a:pPr marL="0" indent="0" algn="ctr">
               <a:buNone/>
             </a:pPr>
             <a:r>
@@ -12304,7 +12113,7 @@
             <a:prstDash val="solid"/>
           </a:ln>
           <a:effectLst>
-            <a:outerShdw sx="100000" sy="100000" kx="0" ky="0" algn="bl" rotWithShape="0" blurRad="76200" dist="25400" dir="5400000">
+            <a:outerShdw blurRad="76200" dist="25400" dir="5400000" algn="bl" rotWithShape="0">
               <a:srgbClr val="000000">
                 <a:alpha val="8000"/>
               </a:srgbClr>
@@ -12333,7 +12142,7 @@
           <a:bodyPr wrap="square" lIns="0" tIns="0" rIns="0" bIns="0" rtlCol="0" anchor="t"/>
           <a:lstStyle/>
           <a:p>
-            <a:pPr indent="0" marL="0">
+            <a:pPr marL="0" indent="0">
               <a:buNone/>
             </a:pPr>
             <a:r>
@@ -12350,7 +12159,7 @@
             <a:endParaRPr lang="en-US" sz="950" dirty="0"/>
           </a:p>
           <a:p>
-            <a:pPr indent="0" marL="0">
+            <a:pPr marL="0" indent="0">
               <a:buNone/>
             </a:pPr>
             <a:r>
@@ -12367,13 +12176,13 @@
             <a:endParaRPr lang="en-US" sz="950" dirty="0"/>
           </a:p>
           <a:p>
-            <a:pPr indent="0" marL="0">
+            <a:pPr marL="0" indent="0">
               <a:buNone/>
             </a:pPr>
             <a:endParaRPr lang="en-US" sz="950" dirty="0"/>
           </a:p>
           <a:p>
-            <a:pPr indent="0" marL="0">
+            <a:pPr marL="0" indent="0">
               <a:buNone/>
             </a:pPr>
             <a:r>
@@ -12390,7 +12199,7 @@
             <a:endParaRPr lang="en-US" sz="950" dirty="0"/>
           </a:p>
           <a:p>
-            <a:pPr indent="0" marL="0">
+            <a:pPr marL="0" indent="0">
               <a:buNone/>
             </a:pPr>
             <a:r>
@@ -12424,6 +12233,7 @@
         <a:solidFill>
           <a:srgbClr val="F4F7FB"/>
         </a:solidFill>
+        <a:effectLst/>
       </p:bgPr>
     </p:bg>
     <p:spTree>
@@ -12461,7 +12271,7 @@
           <a:bodyPr wrap="square" lIns="0" tIns="0" rIns="0" bIns="0" rtlCol="0" anchor="ctr"/>
           <a:lstStyle/>
           <a:p>
-            <a:pPr indent="0" marL="0">
+            <a:pPr marL="0" indent="0">
               <a:buNone/>
             </a:pPr>
             <a:r>
@@ -12500,7 +12310,7 @@
           <a:bodyPr wrap="square" lIns="0" tIns="0" rIns="0" bIns="0" rtlCol="0" anchor="ctr"/>
           <a:lstStyle/>
           <a:p>
-            <a:pPr algn="r" indent="0" marL="0">
+            <a:pPr marL="0" indent="0" algn="r">
               <a:buNone/>
             </a:pPr>
             <a:r>
@@ -12534,15 +12344,27 @@
         </p:nvGraphicFramePr>
         <p:xfrm>
           <a:off x="457200" y="1188720"/>
-          <a:ext cx="8229600" cy="914400"/>
+          <a:ext cx="8229600" cy="2834640"/>
         </p:xfrm>
         <a:graphic>
           <a:graphicData uri="http://schemas.openxmlformats.org/drawingml/2006/table">
             <a:tbl>
               <a:tblPr/>
               <a:tblGrid>
-                <a:gridCol w="1463040"/>
-                <a:gridCol w="6766560"/>
+                <a:gridCol w="1463040">
+                  <a:extLst>
+                    <a:ext uri="{9D8B030D-6E8A-4147-A177-3AD203B41FA5}">
+                      <a16:colId xmlns:a16="http://schemas.microsoft.com/office/drawing/2014/main" val="20000"/>
+                    </a:ext>
+                  </a:extLst>
+                </a:gridCol>
+                <a:gridCol w="6766560">
+                  <a:extLst>
+                    <a:ext uri="{9D8B030D-6E8A-4147-A177-3AD203B41FA5}">
+                      <a16:colId xmlns:a16="http://schemas.microsoft.com/office/drawing/2014/main" val="20001"/>
+                    </a:ext>
+                  </a:extLst>
+                </a:gridCol>
               </a:tblGrid>
               <a:tr h="566928">
                 <a:tc>
@@ -12550,7 +12372,7 @@
                     <a:bodyPr/>
                     <a:lstStyle/>
                     <a:p>
-                      <a:pPr indent="0" marL="0">
+                      <a:pPr marL="0" indent="0">
                         <a:buNone/>
                       </a:pPr>
                       <a:r>
@@ -12618,7 +12440,7 @@
                     <a:bodyPr/>
                     <a:lstStyle/>
                     <a:p>
-                      <a:pPr indent="0" marL="0">
+                      <a:pPr marL="0" indent="0">
                         <a:buNone/>
                       </a:pPr>
                       <a:r>
@@ -12681,6 +12503,11 @@
                     </a:solidFill>
                   </a:tcPr>
                 </a:tc>
+                <a:extLst>
+                  <a:ext uri="{0D108BD9-81ED-4DB2-BD59-A6C34878D82A}">
+                    <a16:rowId xmlns:a16="http://schemas.microsoft.com/office/drawing/2014/main" val="10000"/>
+                  </a:ext>
+                </a:extLst>
               </a:tr>
               <a:tr h="566928">
                 <a:tc>
@@ -12688,7 +12515,7 @@
                     <a:bodyPr/>
                     <a:lstStyle/>
                     <a:p>
-                      <a:pPr indent="0" marL="0">
+                      <a:pPr marL="0" indent="0">
                         <a:buNone/>
                       </a:pPr>
                       <a:r>
@@ -12756,7 +12583,7 @@
                     <a:bodyPr/>
                     <a:lstStyle/>
                     <a:p>
-                      <a:pPr indent="0" marL="0">
+                      <a:pPr marL="0" indent="0">
                         <a:buNone/>
                       </a:pPr>
                       <a:r>
@@ -12819,6 +12646,11 @@
                     </a:solidFill>
                   </a:tcPr>
                 </a:tc>
+                <a:extLst>
+                  <a:ext uri="{0D108BD9-81ED-4DB2-BD59-A6C34878D82A}">
+                    <a16:rowId xmlns:a16="http://schemas.microsoft.com/office/drawing/2014/main" val="10001"/>
+                  </a:ext>
+                </a:extLst>
               </a:tr>
               <a:tr h="566928">
                 <a:tc>
@@ -12826,7 +12658,7 @@
                     <a:bodyPr/>
                     <a:lstStyle/>
                     <a:p>
-                      <a:pPr indent="0" marL="0">
+                      <a:pPr marL="0" indent="0">
                         <a:buNone/>
                       </a:pPr>
                       <a:r>
@@ -12894,7 +12726,7 @@
                     <a:bodyPr/>
                     <a:lstStyle/>
                     <a:p>
-                      <a:pPr indent="0" marL="0">
+                      <a:pPr marL="0" indent="0">
                         <a:buNone/>
                       </a:pPr>
                       <a:r>
@@ -12957,6 +12789,11 @@
                     </a:solidFill>
                   </a:tcPr>
                 </a:tc>
+                <a:extLst>
+                  <a:ext uri="{0D108BD9-81ED-4DB2-BD59-A6C34878D82A}">
+                    <a16:rowId xmlns:a16="http://schemas.microsoft.com/office/drawing/2014/main" val="10002"/>
+                  </a:ext>
+                </a:extLst>
               </a:tr>
               <a:tr h="566928">
                 <a:tc>
@@ -12964,7 +12801,7 @@
                     <a:bodyPr/>
                     <a:lstStyle/>
                     <a:p>
-                      <a:pPr indent="0" marL="0">
+                      <a:pPr marL="0" indent="0">
                         <a:buNone/>
                       </a:pPr>
                       <a:r>
@@ -13032,7 +12869,7 @@
                     <a:bodyPr/>
                     <a:lstStyle/>
                     <a:p>
-                      <a:pPr indent="0" marL="0">
+                      <a:pPr marL="0" indent="0">
                         <a:buNone/>
                       </a:pPr>
                       <a:r>
@@ -13095,6 +12932,11 @@
                     </a:solidFill>
                   </a:tcPr>
                 </a:tc>
+                <a:extLst>
+                  <a:ext uri="{0D108BD9-81ED-4DB2-BD59-A6C34878D82A}">
+                    <a16:rowId xmlns:a16="http://schemas.microsoft.com/office/drawing/2014/main" val="10003"/>
+                  </a:ext>
+                </a:extLst>
               </a:tr>
               <a:tr h="566928">
                 <a:tc>
@@ -13102,7 +12944,7 @@
                     <a:bodyPr/>
                     <a:lstStyle/>
                     <a:p>
-                      <a:pPr indent="0" marL="0">
+                      <a:pPr marL="0" indent="0">
                         <a:buNone/>
                       </a:pPr>
                       <a:r>
@@ -13170,7 +13012,7 @@
                     <a:bodyPr/>
                     <a:lstStyle/>
                     <a:p>
-                      <a:pPr indent="0" marL="0">
+                      <a:pPr marL="0" indent="0">
                         <a:buNone/>
                       </a:pPr>
                       <a:r>
@@ -13233,6 +13075,11 @@
                     </a:solidFill>
                   </a:tcPr>
                 </a:tc>
+                <a:extLst>
+                  <a:ext uri="{0D108BD9-81ED-4DB2-BD59-A6C34878D82A}">
+                    <a16:rowId xmlns:a16="http://schemas.microsoft.com/office/drawing/2014/main" val="10004"/>
+                  </a:ext>
+                </a:extLst>
               </a:tr>
             </a:tbl>
           </a:graphicData>
@@ -13259,7 +13106,7 @@
           <a:bodyPr wrap="square" lIns="0" tIns="0" rIns="0" bIns="0" rtlCol="0" anchor="t"/>
           <a:lstStyle/>
           <a:p>
-            <a:pPr indent="0" marL="0">
+            <a:pPr marL="0" indent="0">
               <a:buNone/>
             </a:pPr>
             <a:r>
@@ -13293,6 +13140,7 @@
         <a:solidFill>
           <a:srgbClr val="F4F7FB"/>
         </a:solidFill>
+        <a:effectLst/>
       </p:bgPr>
     </p:bg>
     <p:spTree>
@@ -13330,7 +13178,7 @@
           <a:bodyPr wrap="square" lIns="0" tIns="0" rIns="0" bIns="0" rtlCol="0" anchor="ctr"/>
           <a:lstStyle/>
           <a:p>
-            <a:pPr indent="0" marL="0">
+            <a:pPr marL="0" indent="0">
               <a:buNone/>
             </a:pPr>
             <a:r>
@@ -13369,7 +13217,7 @@
           <a:bodyPr wrap="square" lIns="0" tIns="0" rIns="0" bIns="0" rtlCol="0" anchor="ctr"/>
           <a:lstStyle/>
           <a:p>
-            <a:pPr indent="0" marL="0">
+            <a:pPr marL="0" indent="0">
               <a:buNone/>
             </a:pPr>
             <a:r>
@@ -13408,7 +13256,7 @@
           <a:bodyPr wrap="square" lIns="0" tIns="0" rIns="0" bIns="0" rtlCol="0" anchor="ctr"/>
           <a:lstStyle/>
           <a:p>
-            <a:pPr algn="r" indent="0" marL="0">
+            <a:pPr marL="0" indent="0" algn="r">
               <a:buNone/>
             </a:pPr>
             <a:r>
@@ -13452,7 +13300,7 @@
             <a:prstDash val="solid"/>
           </a:ln>
           <a:effectLst>
-            <a:outerShdw sx="100000" sy="100000" kx="0" ky="0" algn="bl" rotWithShape="0" blurRad="76200" dist="25400" dir="5400000">
+            <a:outerShdw blurRad="76200" dist="25400" dir="5400000" algn="bl" rotWithShape="0">
               <a:srgbClr val="000000">
                 <a:alpha val="8000"/>
               </a:srgbClr>
@@ -13506,7 +13354,7 @@
           <a:bodyPr wrap="square" lIns="0" tIns="0" rIns="0" bIns="0" rtlCol="0" anchor="t"/>
           <a:lstStyle/>
           <a:p>
-            <a:pPr indent="0" marL="0">
+            <a:pPr marL="0" indent="0">
               <a:buNone/>
             </a:pPr>
             <a:r>
@@ -13545,7 +13393,7 @@
           <a:bodyPr wrap="square" lIns="0" tIns="0" rIns="0" bIns="0" rtlCol="0" anchor="t"/>
           <a:lstStyle/>
           <a:p>
-            <a:pPr indent="0" marL="0">
+            <a:pPr marL="0" indent="0">
               <a:buNone/>
             </a:pPr>
             <a:r>
@@ -13589,7 +13437,7 @@
             <a:prstDash val="solid"/>
           </a:ln>
           <a:effectLst>
-            <a:outerShdw sx="100000" sy="100000" kx="0" ky="0" algn="bl" rotWithShape="0" blurRad="76200" dist="25400" dir="5400000">
+            <a:outerShdw blurRad="76200" dist="25400" dir="5400000" algn="bl" rotWithShape="0">
               <a:srgbClr val="000000">
                 <a:alpha val="8000"/>
               </a:srgbClr>
@@ -13643,7 +13491,7 @@
           <a:bodyPr wrap="square" lIns="0" tIns="0" rIns="0" bIns="0" rtlCol="0" anchor="t"/>
           <a:lstStyle/>
           <a:p>
-            <a:pPr indent="0" marL="0">
+            <a:pPr marL="0" indent="0">
               <a:buNone/>
             </a:pPr>
             <a:r>
@@ -13682,7 +13530,7 @@
           <a:bodyPr wrap="square" lIns="0" tIns="0" rIns="0" bIns="0" rtlCol="0" anchor="t"/>
           <a:lstStyle/>
           <a:p>
-            <a:pPr indent="0" marL="0">
+            <a:pPr marL="0" indent="0">
               <a:buNone/>
             </a:pPr>
             <a:r>
@@ -13726,7 +13574,7 @@
             <a:prstDash val="solid"/>
           </a:ln>
           <a:effectLst>
-            <a:outerShdw sx="100000" sy="100000" kx="0" ky="0" algn="bl" rotWithShape="0" blurRad="76200" dist="25400" dir="5400000">
+            <a:outerShdw blurRad="76200" dist="25400" dir="5400000" algn="bl" rotWithShape="0">
               <a:srgbClr val="000000">
                 <a:alpha val="8000"/>
               </a:srgbClr>
@@ -13780,7 +13628,7 @@
           <a:bodyPr wrap="square" lIns="0" tIns="0" rIns="0" bIns="0" rtlCol="0" anchor="t"/>
           <a:lstStyle/>
           <a:p>
-            <a:pPr indent="0" marL="0">
+            <a:pPr marL="0" indent="0">
               <a:buNone/>
             </a:pPr>
             <a:r>
@@ -13819,7 +13667,7 @@
           <a:bodyPr wrap="square" lIns="0" tIns="0" rIns="0" bIns="0" rtlCol="0" anchor="t"/>
           <a:lstStyle/>
           <a:p>
-            <a:pPr indent="0" marL="0">
+            <a:pPr marL="0" indent="0">
               <a:buNone/>
             </a:pPr>
             <a:r>
@@ -13863,7 +13711,7 @@
             <a:prstDash val="solid"/>
           </a:ln>
           <a:effectLst>
-            <a:outerShdw sx="100000" sy="100000" kx="0" ky="0" algn="bl" rotWithShape="0" blurRad="76200" dist="25400" dir="5400000">
+            <a:outerShdw blurRad="76200" dist="25400" dir="5400000" algn="bl" rotWithShape="0">
               <a:srgbClr val="000000">
                 <a:alpha val="8000"/>
               </a:srgbClr>
@@ -13917,7 +13765,7 @@
           <a:bodyPr wrap="square" lIns="0" tIns="0" rIns="0" bIns="0" rtlCol="0" anchor="t"/>
           <a:lstStyle/>
           <a:p>
-            <a:pPr indent="0" marL="0">
+            <a:pPr marL="0" indent="0">
               <a:buNone/>
             </a:pPr>
             <a:r>
@@ -13956,7 +13804,7 @@
           <a:bodyPr wrap="square" lIns="0" tIns="0" rIns="0" bIns="0" rtlCol="0" anchor="t"/>
           <a:lstStyle/>
           <a:p>
-            <a:pPr indent="0" marL="0">
+            <a:pPr marL="0" indent="0">
               <a:buNone/>
             </a:pPr>
             <a:r>
@@ -14000,7 +13848,7 @@
             <a:prstDash val="solid"/>
           </a:ln>
           <a:effectLst>
-            <a:outerShdw sx="100000" sy="100000" kx="0" ky="0" algn="bl" rotWithShape="0" blurRad="76200" dist="25400" dir="5400000">
+            <a:outerShdw blurRad="76200" dist="25400" dir="5400000" algn="bl" rotWithShape="0">
               <a:srgbClr val="000000">
                 <a:alpha val="8000"/>
               </a:srgbClr>
@@ -14029,7 +13877,7 @@
           <a:bodyPr wrap="square" lIns="0" tIns="0" rIns="0" bIns="0" rtlCol="0" anchor="t"/>
           <a:lstStyle/>
           <a:p>
-            <a:pPr indent="0" marL="0">
+            <a:pPr marL="0" indent="0">
               <a:buNone/>
             </a:pPr>
             <a:r>
@@ -14063,6 +13911,7 @@
         <a:solidFill>
           <a:srgbClr val="F4F7FB"/>
         </a:solidFill>
+        <a:effectLst/>
       </p:bgPr>
     </p:bg>
     <p:spTree>
@@ -14100,7 +13949,7 @@
           <a:bodyPr wrap="square" lIns="0" tIns="0" rIns="0" bIns="0" rtlCol="0" anchor="ctr"/>
           <a:lstStyle/>
           <a:p>
-            <a:pPr indent="0" marL="0">
+            <a:pPr marL="0" indent="0">
               <a:buNone/>
             </a:pPr>
             <a:r>
@@ -14139,7 +13988,7 @@
           <a:bodyPr wrap="square" lIns="0" tIns="0" rIns="0" bIns="0" rtlCol="0" anchor="ctr"/>
           <a:lstStyle/>
           <a:p>
-            <a:pPr indent="0" marL="0">
+            <a:pPr marL="0" indent="0">
               <a:buNone/>
             </a:pPr>
             <a:r>
@@ -14178,7 +14027,7 @@
           <a:bodyPr wrap="square" lIns="0" tIns="0" rIns="0" bIns="0" rtlCol="0" anchor="ctr"/>
           <a:lstStyle/>
           <a:p>
-            <a:pPr algn="r" indent="0" marL="0">
+            <a:pPr marL="0" indent="0" algn="r">
               <a:buNone/>
             </a:pPr>
             <a:r>
@@ -14222,7 +14071,7 @@
             <a:prstDash val="solid"/>
           </a:ln>
           <a:effectLst>
-            <a:outerShdw sx="100000" sy="100000" kx="0" ky="0" algn="bl" rotWithShape="0" blurRad="76200" dist="25400" dir="5400000">
+            <a:outerShdw blurRad="76200" dist="25400" dir="5400000" algn="bl" rotWithShape="0">
               <a:srgbClr val="000000">
                 <a:alpha val="8000"/>
               </a:srgbClr>
@@ -14251,7 +14100,7 @@
           <a:bodyPr wrap="square" lIns="0" tIns="0" rIns="0" bIns="0" rtlCol="0" anchor="ctr"/>
           <a:lstStyle/>
           <a:p>
-            <a:pPr indent="0" marL="0">
+            <a:pPr marL="0" indent="0">
               <a:buNone/>
             </a:pPr>
             <a:r>
@@ -14290,7 +14139,7 @@
           <a:bodyPr wrap="square" lIns="0" tIns="0" rIns="0" bIns="0" rtlCol="0" anchor="ctr"/>
           <a:lstStyle/>
           <a:p>
-            <a:pPr indent="0" marL="0">
+            <a:pPr marL="0" indent="0">
               <a:buNone/>
             </a:pPr>
             <a:r>
@@ -14334,7 +14183,7 @@
             <a:prstDash val="solid"/>
           </a:ln>
           <a:effectLst>
-            <a:outerShdw sx="100000" sy="100000" kx="0" ky="0" algn="bl" rotWithShape="0" blurRad="76200" dist="25400" dir="5400000">
+            <a:outerShdw blurRad="76200" dist="25400" dir="5400000" algn="bl" rotWithShape="0">
               <a:srgbClr val="000000">
                 <a:alpha val="8000"/>
               </a:srgbClr>
@@ -14363,7 +14212,7 @@
           <a:bodyPr wrap="square" lIns="0" tIns="0" rIns="0" bIns="0" rtlCol="0" anchor="ctr"/>
           <a:lstStyle/>
           <a:p>
-            <a:pPr indent="0" marL="0">
+            <a:pPr marL="0" indent="0">
               <a:buNone/>
             </a:pPr>
             <a:r>
@@ -14402,7 +14251,7 @@
           <a:bodyPr wrap="square" lIns="0" tIns="0" rIns="0" bIns="0" rtlCol="0" anchor="ctr"/>
           <a:lstStyle/>
           <a:p>
-            <a:pPr indent="0" marL="0">
+            <a:pPr marL="0" indent="0">
               <a:buNone/>
             </a:pPr>
             <a:r>
@@ -14446,7 +14295,7 @@
             <a:prstDash val="solid"/>
           </a:ln>
           <a:effectLst>
-            <a:outerShdw sx="100000" sy="100000" kx="0" ky="0" algn="bl" rotWithShape="0" blurRad="76200" dist="25400" dir="5400000">
+            <a:outerShdw blurRad="76200" dist="25400" dir="5400000" algn="bl" rotWithShape="0">
               <a:srgbClr val="000000">
                 <a:alpha val="8000"/>
               </a:srgbClr>
@@ -14475,7 +14324,7 @@
           <a:bodyPr wrap="square" lIns="0" tIns="0" rIns="0" bIns="0" rtlCol="0" anchor="ctr"/>
           <a:lstStyle/>
           <a:p>
-            <a:pPr indent="0" marL="0">
+            <a:pPr marL="0" indent="0">
               <a:buNone/>
             </a:pPr>
             <a:r>
@@ -14514,7 +14363,7 @@
           <a:bodyPr wrap="square" lIns="0" tIns="0" rIns="0" bIns="0" rtlCol="0" anchor="ctr"/>
           <a:lstStyle/>
           <a:p>
-            <a:pPr indent="0" marL="0">
+            <a:pPr marL="0" indent="0">
               <a:buNone/>
             </a:pPr>
             <a:r>
@@ -14706,7 +14555,7 @@
             <a:prstDash val="solid"/>
           </a:ln>
           <a:effectLst>
-            <a:outerShdw sx="100000" sy="100000" kx="0" ky="0" algn="bl" rotWithShape="0" blurRad="76200" dist="25400" dir="5400000">
+            <a:outerShdw blurRad="76200" dist="25400" dir="5400000" algn="bl" rotWithShape="0">
               <a:srgbClr val="000000">
                 <a:alpha val="8000"/>
               </a:srgbClr>
@@ -14735,7 +14584,7 @@
           <a:bodyPr wrap="square" lIns="0" tIns="0" rIns="0" bIns="0" rtlCol="0" anchor="ctr"/>
           <a:lstStyle/>
           <a:p>
-            <a:pPr indent="0" marL="0">
+            <a:pPr marL="0" indent="0">
               <a:buNone/>
             </a:pPr>
             <a:r>
@@ -14774,7 +14623,7 @@
           <a:bodyPr wrap="square" lIns="0" tIns="0" rIns="0" bIns="0" rtlCol="0" anchor="t"/>
           <a:lstStyle/>
           <a:p>
-            <a:pPr indent="0" marL="0">
+            <a:pPr marL="0" indent="0">
               <a:buNone/>
             </a:pPr>
             <a:r>
@@ -14791,7 +14640,7 @@
             <a:endParaRPr lang="en-US" sz="1100" dirty="0"/>
           </a:p>
           <a:p>
-            <a:pPr indent="0" marL="0">
+            <a:pPr marL="0" indent="0">
               <a:buNone/>
             </a:pPr>
             <a:r>
@@ -14808,7 +14657,7 @@
             <a:endParaRPr lang="en-US" sz="1100" dirty="0"/>
           </a:p>
           <a:p>
-            <a:pPr indent="0" marL="0">
+            <a:pPr marL="0" indent="0">
               <a:buNone/>
             </a:pPr>
             <a:r>
@@ -14825,7 +14674,7 @@
             <a:endParaRPr lang="en-US" sz="1100" dirty="0"/>
           </a:p>
           <a:p>
-            <a:pPr indent="0" marL="0">
+            <a:pPr marL="0" indent="0">
               <a:buNone/>
             </a:pPr>
             <a:r>
@@ -14842,7 +14691,7 @@
             <a:endParaRPr lang="en-US" sz="1100" dirty="0"/>
           </a:p>
           <a:p>
-            <a:pPr indent="0" marL="0">
+            <a:pPr marL="0" indent="0">
               <a:buNone/>
             </a:pPr>
             <a:r>
@@ -14859,7 +14708,7 @@
             <a:endParaRPr lang="en-US" sz="1100" dirty="0"/>
           </a:p>
           <a:p>
-            <a:pPr indent="0" marL="0">
+            <a:pPr marL="0" indent="0">
               <a:buNone/>
             </a:pPr>
             <a:r>
@@ -14893,6 +14742,7 @@
         <a:solidFill>
           <a:srgbClr val="F4F7FB"/>
         </a:solidFill>
+        <a:effectLst/>
       </p:bgPr>
     </p:bg>
     <p:spTree>
@@ -14930,7 +14780,7 @@
           <a:bodyPr wrap="square" lIns="0" tIns="0" rIns="0" bIns="0" rtlCol="0" anchor="ctr"/>
           <a:lstStyle/>
           <a:p>
-            <a:pPr indent="0" marL="0">
+            <a:pPr marL="0" indent="0">
               <a:buNone/>
             </a:pPr>
             <a:r>
@@ -14969,7 +14819,7 @@
           <a:bodyPr wrap="square" lIns="0" tIns="0" rIns="0" bIns="0" rtlCol="0" anchor="ctr"/>
           <a:lstStyle/>
           <a:p>
-            <a:pPr indent="0" marL="0">
+            <a:pPr marL="0" indent="0">
               <a:buNone/>
             </a:pPr>
             <a:r>
@@ -15008,7 +14858,7 @@
           <a:bodyPr wrap="square" lIns="0" tIns="0" rIns="0" bIns="0" rtlCol="0" anchor="ctr"/>
           <a:lstStyle/>
           <a:p>
-            <a:pPr algn="r" indent="0" marL="0">
+            <a:pPr marL="0" indent="0" algn="r">
               <a:buNone/>
             </a:pPr>
             <a:r>
@@ -15052,7 +14902,7 @@
             <a:prstDash val="solid"/>
           </a:ln>
           <a:effectLst>
-            <a:outerShdw sx="100000" sy="100000" kx="0" ky="0" algn="bl" rotWithShape="0" blurRad="101600" dist="38100" dir="5400000">
+            <a:outerShdw blurRad="101600" dist="38100" dir="5400000" algn="bl" rotWithShape="0">
               <a:srgbClr val="000000">
                 <a:alpha val="25000"/>
               </a:srgbClr>
@@ -15062,14 +14912,14 @@
       </p:sp>
       <p:pic>
         <p:nvPicPr>
-          <p:cNvPr id="6" name="Image 0" descr="C:/Users/ayush/Documents/PingHome/docs/screenshots/home_light.png">    </p:cNvPr>
+          <p:cNvPr id="6" name="Image 0" descr="C:/Users/ayush/Documents/PingHome/docs/screenshots/home_light.png"/>
           <p:cNvPicPr>
             <a:picLocks noChangeAspect="1"/>
           </p:cNvPicPr>
           <p:nvPr/>
         </p:nvPicPr>
         <p:blipFill>
-          <a:blip r:embed="rId1"/>
+          <a:blip r:embed="rId3"/>
           <a:stretch>
             <a:fillRect/>
           </a:stretch>
@@ -15105,7 +14955,7 @@
           <a:bodyPr wrap="square" lIns="0" tIns="0" rIns="0" bIns="0" rtlCol="0" anchor="ctr"/>
           <a:lstStyle/>
           <a:p>
-            <a:pPr algn="ctr" indent="0" marL="0">
+            <a:pPr marL="0" indent="0" algn="ctr">
               <a:buNone/>
             </a:pPr>
             <a:r>
@@ -15149,7 +14999,7 @@
             <a:prstDash val="solid"/>
           </a:ln>
           <a:effectLst>
-            <a:outerShdw sx="100000" sy="100000" kx="0" ky="0" algn="bl" rotWithShape="0" blurRad="101600" dist="38100" dir="5400000">
+            <a:outerShdw blurRad="101600" dist="38100" dir="5400000" algn="bl" rotWithShape="0">
               <a:srgbClr val="000000">
                 <a:alpha val="25000"/>
               </a:srgbClr>
@@ -15159,14 +15009,14 @@
       </p:sp>
       <p:pic>
         <p:nvPicPr>
-          <p:cNvPr id="9" name="Image 1" descr="C:/Users/ayush/Documents/PingHome/docs/screenshots/new_trip_map.png">    </p:cNvPr>
+          <p:cNvPr id="9" name="Image 1" descr="C:/Users/ayush/Documents/PingHome/docs/screenshots/new_trip_map.png"/>
           <p:cNvPicPr>
             <a:picLocks noChangeAspect="1"/>
           </p:cNvPicPr>
           <p:nvPr/>
         </p:nvPicPr>
         <p:blipFill>
-          <a:blip r:embed="rId2"/>
+          <a:blip r:embed="rId4"/>
           <a:stretch>
             <a:fillRect/>
           </a:stretch>
@@ -15202,7 +15052,7 @@
           <a:bodyPr wrap="square" lIns="0" tIns="0" rIns="0" bIns="0" rtlCol="0" anchor="ctr"/>
           <a:lstStyle/>
           <a:p>
-            <a:pPr algn="ctr" indent="0" marL="0">
+            <a:pPr marL="0" indent="0" algn="ctr">
               <a:buNone/>
             </a:pPr>
             <a:r>
@@ -15246,7 +15096,7 @@
             <a:prstDash val="solid"/>
           </a:ln>
           <a:effectLst>
-            <a:outerShdw sx="100000" sy="100000" kx="0" ky="0" algn="bl" rotWithShape="0" blurRad="101600" dist="38100" dir="5400000">
+            <a:outerShdw blurRad="101600" dist="38100" dir="5400000" algn="bl" rotWithShape="0">
               <a:srgbClr val="000000">
                 <a:alpha val="25000"/>
               </a:srgbClr>
@@ -15256,14 +15106,14 @@
       </p:sp>
       <p:pic>
         <p:nvPicPr>
-          <p:cNvPr id="12" name="Image 2" descr="C:/Users/ayush/Documents/PingHome/docs/screenshots/circle.png">    </p:cNvPr>
+          <p:cNvPr id="12" name="Image 2" descr="C:/Users/ayush/Documents/PingHome/docs/screenshots/circle.png"/>
           <p:cNvPicPr>
             <a:picLocks noChangeAspect="1"/>
           </p:cNvPicPr>
           <p:nvPr/>
         </p:nvPicPr>
         <p:blipFill>
-          <a:blip r:embed="rId3"/>
+          <a:blip r:embed="rId5"/>
           <a:stretch>
             <a:fillRect/>
           </a:stretch>
@@ -15299,7 +15149,7 @@
           <a:bodyPr wrap="square" lIns="0" tIns="0" rIns="0" bIns="0" rtlCol="0" anchor="ctr"/>
           <a:lstStyle/>
           <a:p>
-            <a:pPr algn="ctr" indent="0" marL="0">
+            <a:pPr marL="0" indent="0" algn="ctr">
               <a:buNone/>
             </a:pPr>
             <a:r>
@@ -15481,6 +15331,7 @@
         <a:solidFill>
           <a:srgbClr val="F4F7FB"/>
         </a:solidFill>
+        <a:effectLst/>
       </p:bgPr>
     </p:bg>
     <p:spTree>
@@ -15518,7 +15369,7 @@
           <a:bodyPr wrap="square" lIns="0" tIns="0" rIns="0" bIns="0" rtlCol="0" anchor="ctr"/>
           <a:lstStyle/>
           <a:p>
-            <a:pPr indent="0" marL="0">
+            <a:pPr marL="0" indent="0">
               <a:buNone/>
             </a:pPr>
             <a:r>
@@ -15557,7 +15408,7 @@
           <a:bodyPr wrap="square" lIns="0" tIns="0" rIns="0" bIns="0" rtlCol="0" anchor="ctr"/>
           <a:lstStyle/>
           <a:p>
-            <a:pPr indent="0" marL="0">
+            <a:pPr marL="0" indent="0">
               <a:buNone/>
             </a:pPr>
             <a:r>
@@ -15596,7 +15447,7 @@
           <a:bodyPr wrap="square" lIns="0" tIns="0" rIns="0" bIns="0" rtlCol="0" anchor="ctr"/>
           <a:lstStyle/>
           <a:p>
-            <a:pPr algn="r" indent="0" marL="0">
+            <a:pPr marL="0" indent="0" algn="r">
               <a:buNone/>
             </a:pPr>
             <a:r>
@@ -15640,7 +15491,7 @@
             <a:prstDash val="solid"/>
           </a:ln>
           <a:effectLst>
-            <a:outerShdw sx="100000" sy="100000" kx="0" ky="0" algn="bl" rotWithShape="0" blurRad="101600" dist="38100" dir="5400000">
+            <a:outerShdw blurRad="101600" dist="38100" dir="5400000" algn="bl" rotWithShape="0">
               <a:srgbClr val="000000">
                 <a:alpha val="25000"/>
               </a:srgbClr>
@@ -15650,14 +15501,14 @@
       </p:sp>
       <p:pic>
         <p:nvPicPr>
-          <p:cNvPr id="6" name="Image 0" descr="C:/Users/ayush/Documents/PingHome/docs/screenshots/active_trip.png">    </p:cNvPr>
+          <p:cNvPr id="6" name="Image 0" descr="C:/Users/ayush/Documents/PingHome/docs/screenshots/active_trip.png"/>
           <p:cNvPicPr>
             <a:picLocks noChangeAspect="1"/>
           </p:cNvPicPr>
           <p:nvPr/>
         </p:nvPicPr>
         <p:blipFill>
-          <a:blip r:embed="rId1"/>
+          <a:blip r:embed="rId3"/>
           <a:stretch>
             <a:fillRect/>
           </a:stretch>
@@ -15693,7 +15544,7 @@
           <a:bodyPr wrap="square" lIns="0" tIns="0" rIns="0" bIns="0" rtlCol="0" anchor="ctr"/>
           <a:lstStyle/>
           <a:p>
-            <a:pPr algn="ctr" indent="0" marL="0">
+            <a:pPr marL="0" indent="0" algn="ctr">
               <a:buNone/>
             </a:pPr>
             <a:r>
@@ -15737,7 +15588,7 @@
             <a:prstDash val="solid"/>
           </a:ln>
           <a:effectLst>
-            <a:outerShdw sx="100000" sy="100000" kx="0" ky="0" algn="bl" rotWithShape="0" blurRad="101600" dist="38100" dir="5400000">
+            <a:outerShdw blurRad="101600" dist="38100" dir="5400000" algn="bl" rotWithShape="0">
               <a:srgbClr val="000000">
                 <a:alpha val="25000"/>
               </a:srgbClr>
@@ -15747,14 +15598,14 @@
       </p:sp>
       <p:pic>
         <p:nvPicPr>
-          <p:cNvPr id="9" name="Image 1" descr="C:/Users/ayush/Documents/PingHome/docs/screenshots/trips.png">    </p:cNvPr>
+          <p:cNvPr id="9" name="Image 1" descr="C:/Users/ayush/Documents/PingHome/docs/screenshots/trips.png"/>
           <p:cNvPicPr>
             <a:picLocks noChangeAspect="1"/>
           </p:cNvPicPr>
           <p:nvPr/>
         </p:nvPicPr>
         <p:blipFill>
-          <a:blip r:embed="rId2"/>
+          <a:blip r:embed="rId4"/>
           <a:stretch>
             <a:fillRect/>
           </a:stretch>
@@ -15790,7 +15641,7 @@
           <a:bodyPr wrap="square" lIns="0" tIns="0" rIns="0" bIns="0" rtlCol="0" anchor="ctr"/>
           <a:lstStyle/>
           <a:p>
-            <a:pPr algn="ctr" indent="0" marL="0">
+            <a:pPr marL="0" indent="0" algn="ctr">
               <a:buNone/>
             </a:pPr>
             <a:r>
@@ -15834,7 +15685,7 @@
             <a:prstDash val="solid"/>
           </a:ln>
           <a:effectLst>
-            <a:outerShdw sx="100000" sy="100000" kx="0" ky="0" algn="bl" rotWithShape="0" blurRad="101600" dist="38100" dir="5400000">
+            <a:outerShdw blurRad="101600" dist="38100" dir="5400000" algn="bl" rotWithShape="0">
               <a:srgbClr val="000000">
                 <a:alpha val="25000"/>
               </a:srgbClr>
@@ -15844,14 +15695,14 @@
       </p:sp>
       <p:pic>
         <p:nvPicPr>
-          <p:cNvPr id="12" name="Image 2" descr="C:/Users/ayush/Documents/PingHome/docs/screenshots/profile.png">    </p:cNvPr>
+          <p:cNvPr id="12" name="Image 2" descr="C:/Users/ayush/Documents/PingHome/docs/screenshots/profile.png"/>
           <p:cNvPicPr>
             <a:picLocks noChangeAspect="1"/>
           </p:cNvPicPr>
           <p:nvPr/>
         </p:nvPicPr>
         <p:blipFill>
-          <a:blip r:embed="rId3"/>
+          <a:blip r:embed="rId5"/>
           <a:stretch>
             <a:fillRect/>
           </a:stretch>
@@ -15887,7 +15738,7 @@
           <a:bodyPr wrap="square" lIns="0" tIns="0" rIns="0" bIns="0" rtlCol="0" anchor="ctr"/>
           <a:lstStyle/>
           <a:p>
-            <a:pPr algn="ctr" indent="0" marL="0">
+            <a:pPr marL="0" indent="0" algn="ctr">
               <a:buNone/>
             </a:pPr>
             <a:r>
@@ -15931,7 +15782,7 @@
             <a:prstDash val="solid"/>
           </a:ln>
           <a:effectLst>
-            <a:outerShdw sx="100000" sy="100000" kx="0" ky="0" algn="bl" rotWithShape="0" blurRad="101600" dist="38100" dir="5400000">
+            <a:outerShdw blurRad="101600" dist="38100" dir="5400000" algn="bl" rotWithShape="0">
               <a:srgbClr val="000000">
                 <a:alpha val="25000"/>
               </a:srgbClr>
@@ -15941,14 +15792,14 @@
       </p:sp>
       <p:pic>
         <p:nvPicPr>
-          <p:cNvPr id="15" name="Image 3" descr="C:/Users/ayush/Documents/PingHome/docs/screenshots/home_dark.png">    </p:cNvPr>
+          <p:cNvPr id="15" name="Image 3" descr="C:/Users/ayush/Documents/PingHome/docs/screenshots/home_dark.png"/>
           <p:cNvPicPr>
             <a:picLocks noChangeAspect="1"/>
           </p:cNvPicPr>
           <p:nvPr/>
         </p:nvPicPr>
         <p:blipFill>
-          <a:blip r:embed="rId4"/>
+          <a:blip r:embed="rId6"/>
           <a:stretch>
             <a:fillRect/>
           </a:stretch>
@@ -15984,7 +15835,7 @@
           <a:bodyPr wrap="square" lIns="0" tIns="0" rIns="0" bIns="0" rtlCol="0" anchor="ctr"/>
           <a:lstStyle/>
           <a:p>
-            <a:pPr algn="ctr" indent="0" marL="0">
+            <a:pPr marL="0" indent="0" algn="ctr">
               <a:buNone/>
             </a:pPr>
             <a:r>
@@ -16303,4 +16154,299 @@
     </a:ext>
   </a:extLst>
 </a:theme>
+</file>
+
+<file path=ppt/theme/theme2.xml><?xml version="1.0" encoding="utf-8"?>
+<a:theme xmlns:a="http://schemas.openxmlformats.org/drawingml/2006/main" name="Office Theme">
+  <a:themeElements>
+    <a:clrScheme name="Office">
+      <a:dk1>
+        <a:sysClr val="windowText" lastClr="000000"/>
+      </a:dk1>
+      <a:lt1>
+        <a:sysClr val="window" lastClr="FFFFFF"/>
+      </a:lt1>
+      <a:dk2>
+        <a:srgbClr val="44546A"/>
+      </a:dk2>
+      <a:lt2>
+        <a:srgbClr val="E7E6E6"/>
+      </a:lt2>
+      <a:accent1>
+        <a:srgbClr val="4472C4"/>
+      </a:accent1>
+      <a:accent2>
+        <a:srgbClr val="ED7D31"/>
+      </a:accent2>
+      <a:accent3>
+        <a:srgbClr val="A5A5A5"/>
+      </a:accent3>
+      <a:accent4>
+        <a:srgbClr val="FFC000"/>
+      </a:accent4>
+      <a:accent5>
+        <a:srgbClr val="5B9BD5"/>
+      </a:accent5>
+      <a:accent6>
+        <a:srgbClr val="70AD47"/>
+      </a:accent6>
+      <a:hlink>
+        <a:srgbClr val="0563C1"/>
+      </a:hlink>
+      <a:folHlink>
+        <a:srgbClr val="954F72"/>
+      </a:folHlink>
+    </a:clrScheme>
+    <a:fontScheme name="Office">
+      <a:majorFont>
+        <a:latin typeface="Calibri Light" panose="020F0302020204030204"/>
+        <a:ea typeface=""/>
+        <a:cs typeface=""/>
+        <a:font script="Jpan" typeface="游ゴシック Light"/>
+        <a:font script="Hang" typeface="맑은 고딕"/>
+        <a:font script="Hans" typeface="等线 Light"/>
+        <a:font script="Hant" typeface="新細明體"/>
+        <a:font script="Arab" typeface="Times New Roman"/>
+        <a:font script="Hebr" typeface="Times New Roman"/>
+        <a:font script="Thai" typeface="Angsana New"/>
+        <a:font script="Ethi" typeface="Nyala"/>
+        <a:font script="Beng" typeface="Vrinda"/>
+        <a:font script="Gujr" typeface="Shruti"/>
+        <a:font script="Khmr" typeface="MoolBoran"/>
+        <a:font script="Knda" typeface="Tunga"/>
+        <a:font script="Guru" typeface="Raavi"/>
+        <a:font script="Cans" typeface="Euphemia"/>
+        <a:font script="Cher" typeface="Plantagenet Cherokee"/>
+        <a:font script="Yiii" typeface="Microsoft Yi Baiti"/>
+        <a:font script="Tibt" typeface="Microsoft Himalaya"/>
+        <a:font script="Thaa" typeface="MV Boli"/>
+        <a:font script="Deva" typeface="Mangal"/>
+        <a:font script="Telu" typeface="Gautami"/>
+        <a:font script="Taml" typeface="Latha"/>
+        <a:font script="Syrc" typeface="Estrangelo Edessa"/>
+        <a:font script="Orya" typeface="Kalinga"/>
+        <a:font script="Mlym" typeface="Kartika"/>
+        <a:font script="Laoo" typeface="DokChampa"/>
+        <a:font script="Sinh" typeface="Iskoola Pota"/>
+        <a:font script="Mong" typeface="Mongolian Baiti"/>
+        <a:font script="Viet" typeface="Times New Roman"/>
+        <a:font script="Uigh" typeface="Microsoft Uighur"/>
+        <a:font script="Geor" typeface="Sylfaen"/>
+        <a:font script="Armn" typeface="Arial"/>
+        <a:font script="Bugi" typeface="Leelawadee UI"/>
+        <a:font script="Bopo" typeface="Microsoft JhengHei"/>
+        <a:font script="Java" typeface="Javanese Text"/>
+        <a:font script="Lisu" typeface="Segoe UI"/>
+        <a:font script="Mymr" typeface="Myanmar Text"/>
+        <a:font script="Nkoo" typeface="Ebrima"/>
+        <a:font script="Olck" typeface="Nirmala UI"/>
+        <a:font script="Osma" typeface="Ebrima"/>
+        <a:font script="Phag" typeface="Phagspa"/>
+        <a:font script="Syrn" typeface="Estrangelo Edessa"/>
+        <a:font script="Syrj" typeface="Estrangelo Edessa"/>
+        <a:font script="Syre" typeface="Estrangelo Edessa"/>
+        <a:font script="Sora" typeface="Nirmala UI"/>
+        <a:font script="Tale" typeface="Microsoft Tai Le"/>
+        <a:font script="Talu" typeface="Microsoft New Tai Lue"/>
+        <a:font script="Tfng" typeface="Ebrima"/>
+      </a:majorFont>
+      <a:minorFont>
+        <a:latin typeface="Calibri" panose="020F0502020204030204"/>
+        <a:ea typeface=""/>
+        <a:cs typeface=""/>
+        <a:font script="Jpan" typeface="游ゴシック"/>
+        <a:font script="Hang" typeface="맑은 고딕"/>
+        <a:font script="Hans" typeface="等线"/>
+        <a:font script="Hant" typeface="新細明體"/>
+        <a:font script="Arab" typeface="Arial"/>
+        <a:font script="Hebr" typeface="Arial"/>
+        <a:font script="Thai" typeface="Cordia New"/>
+        <a:font script="Ethi" typeface="Nyala"/>
+        <a:font script="Beng" typeface="Vrinda"/>
+        <a:font script="Gujr" typeface="Shruti"/>
+        <a:font script="Khmr" typeface="DaunPenh"/>
+        <a:font script="Knda" typeface="Tunga"/>
+        <a:font script="Guru" typeface="Raavi"/>
+        <a:font script="Cans" typeface="Euphemia"/>
+        <a:font script="Cher" typeface="Plantagenet Cherokee"/>
+        <a:font script="Yiii" typeface="Microsoft Yi Baiti"/>
+        <a:font script="Tibt" typeface="Microsoft Himalaya"/>
+        <a:font script="Thaa" typeface="MV Boli"/>
+        <a:font script="Deva" typeface="Mangal"/>
+        <a:font script="Telu" typeface="Gautami"/>
+        <a:font script="Taml" typeface="Latha"/>
+        <a:font script="Syrc" typeface="Estrangelo Edessa"/>
+        <a:font script="Orya" typeface="Kalinga"/>
+        <a:font script="Mlym" typeface="Kartika"/>
+        <a:font script="Laoo" typeface="DokChampa"/>
+        <a:font script="Sinh" typeface="Iskoola Pota"/>
+        <a:font script="Mong" typeface="Mongolian Baiti"/>
+        <a:font script="Viet" typeface="Arial"/>
+        <a:font script="Uigh" typeface="Microsoft Uighur"/>
+        <a:font script="Geor" typeface="Sylfaen"/>
+        <a:font script="Armn" typeface="Arial"/>
+        <a:font script="Bugi" typeface="Leelawadee UI"/>
+        <a:font script="Bopo" typeface="Microsoft JhengHei"/>
+        <a:font script="Java" typeface="Javanese Text"/>
+        <a:font script="Lisu" typeface="Segoe UI"/>
+        <a:font script="Mymr" typeface="Myanmar Text"/>
+        <a:font script="Nkoo" typeface="Ebrima"/>
+        <a:font script="Olck" typeface="Nirmala UI"/>
+        <a:font script="Osma" typeface="Ebrima"/>
+        <a:font script="Phag" typeface="Phagspa"/>
+        <a:font script="Syrn" typeface="Estrangelo Edessa"/>
+        <a:font script="Syrj" typeface="Estrangelo Edessa"/>
+        <a:font script="Syre" typeface="Estrangelo Edessa"/>
+        <a:font script="Sora" typeface="Nirmala UI"/>
+        <a:font script="Tale" typeface="Microsoft Tai Le"/>
+        <a:font script="Talu" typeface="Microsoft New Tai Lue"/>
+        <a:font script="Tfng" typeface="Ebrima"/>
+      </a:minorFont>
+    </a:fontScheme>
+    <a:fmtScheme name="Office">
+      <a:fillStyleLst>
+        <a:solidFill>
+          <a:schemeClr val="phClr"/>
+        </a:solidFill>
+        <a:gradFill rotWithShape="1">
+          <a:gsLst>
+            <a:gs pos="0">
+              <a:schemeClr val="phClr">
+                <a:lumMod val="110000"/>
+                <a:satMod val="105000"/>
+                <a:tint val="67000"/>
+              </a:schemeClr>
+            </a:gs>
+            <a:gs pos="50000">
+              <a:schemeClr val="phClr">
+                <a:lumMod val="105000"/>
+                <a:satMod val="103000"/>
+                <a:tint val="73000"/>
+              </a:schemeClr>
+            </a:gs>
+            <a:gs pos="100000">
+              <a:schemeClr val="phClr">
+                <a:lumMod val="105000"/>
+                <a:satMod val="109000"/>
+                <a:tint val="81000"/>
+              </a:schemeClr>
+            </a:gs>
+          </a:gsLst>
+          <a:lin ang="5400000" scaled="0"/>
+        </a:gradFill>
+        <a:gradFill rotWithShape="1">
+          <a:gsLst>
+            <a:gs pos="0">
+              <a:schemeClr val="phClr">
+                <a:satMod val="103000"/>
+                <a:lumMod val="102000"/>
+                <a:tint val="94000"/>
+              </a:schemeClr>
+            </a:gs>
+            <a:gs pos="50000">
+              <a:schemeClr val="phClr">
+                <a:satMod val="110000"/>
+                <a:lumMod val="100000"/>
+                <a:shade val="100000"/>
+              </a:schemeClr>
+            </a:gs>
+            <a:gs pos="100000">
+              <a:schemeClr val="phClr">
+                <a:lumMod val="99000"/>
+                <a:satMod val="120000"/>
+                <a:shade val="78000"/>
+              </a:schemeClr>
+            </a:gs>
+          </a:gsLst>
+          <a:lin ang="5400000" scaled="0"/>
+        </a:gradFill>
+      </a:fillStyleLst>
+      <a:lnStyleLst>
+        <a:ln w="6350" cap="flat" cmpd="sng" algn="ctr">
+          <a:solidFill>
+            <a:schemeClr val="phClr"/>
+          </a:solidFill>
+          <a:prstDash val="solid"/>
+          <a:miter lim="800000"/>
+        </a:ln>
+        <a:ln w="12700" cap="flat" cmpd="sng" algn="ctr">
+          <a:solidFill>
+            <a:schemeClr val="phClr"/>
+          </a:solidFill>
+          <a:prstDash val="solid"/>
+          <a:miter lim="800000"/>
+        </a:ln>
+        <a:ln w="19050" cap="flat" cmpd="sng" algn="ctr">
+          <a:solidFill>
+            <a:schemeClr val="phClr"/>
+          </a:solidFill>
+          <a:prstDash val="solid"/>
+          <a:miter lim="800000"/>
+        </a:ln>
+      </a:lnStyleLst>
+      <a:effectStyleLst>
+        <a:effectStyle>
+          <a:effectLst/>
+        </a:effectStyle>
+        <a:effectStyle>
+          <a:effectLst/>
+        </a:effectStyle>
+        <a:effectStyle>
+          <a:effectLst>
+            <a:outerShdw blurRad="57150" dist="19050" dir="5400000" algn="ctr" rotWithShape="0">
+              <a:srgbClr val="000000">
+                <a:alpha val="63000"/>
+              </a:srgbClr>
+            </a:outerShdw>
+          </a:effectLst>
+        </a:effectStyle>
+      </a:effectStyleLst>
+      <a:bgFillStyleLst>
+        <a:solidFill>
+          <a:schemeClr val="phClr"/>
+        </a:solidFill>
+        <a:solidFill>
+          <a:schemeClr val="phClr">
+            <a:tint val="95000"/>
+            <a:satMod val="170000"/>
+          </a:schemeClr>
+        </a:solidFill>
+        <a:gradFill rotWithShape="1">
+          <a:gsLst>
+            <a:gs pos="0">
+              <a:schemeClr val="phClr">
+                <a:tint val="93000"/>
+                <a:satMod val="150000"/>
+                <a:shade val="98000"/>
+                <a:lumMod val="102000"/>
+              </a:schemeClr>
+            </a:gs>
+            <a:gs pos="50000">
+              <a:schemeClr val="phClr">
+                <a:tint val="98000"/>
+                <a:satMod val="130000"/>
+                <a:shade val="90000"/>
+                <a:lumMod val="103000"/>
+              </a:schemeClr>
+            </a:gs>
+            <a:gs pos="100000">
+              <a:schemeClr val="phClr">
+                <a:shade val="63000"/>
+                <a:satMod val="120000"/>
+              </a:schemeClr>
+            </a:gs>
+          </a:gsLst>
+          <a:lin ang="5400000" scaled="0"/>
+        </a:gradFill>
+      </a:bgFillStyleLst>
+    </a:fmtScheme>
+  </a:themeElements>
+  <a:objectDefaults/>
+  <a:extraClrSchemeLst/>
+  <a:extLst>
+    <a:ext uri="{05A4C25C-085E-4340-85A3-A5531E510DB2}">
+      <thm15:themeFamily xmlns:thm15="http://schemas.microsoft.com/office/thememl/2012/main" name="Office Theme" id="{62F939B6-93AF-4DB8-9C6B-D6C7DFDC589F}" vid="{4A3C46E8-61CC-4603-A589-7422A47A8E4A}"/>
+    </a:ext>
+  </a:extLst>
+</a:theme>
 </file>
</xml_diff>